<commit_message>
docs: add field mappings slide to developer guide
</commit_message>
<xml_diff>
--- a/PRomop_Developer_Guide.pptx
+++ b/PRomop_Developer_Guide.pptx
@@ -14,7 +14,6 @@
     <p:sldId id="262" r:id="rId13"/>
     <p:sldId id="263" r:id="rId14"/>
     <p:sldId id="264" r:id="rId15"/>
-    <p:sldId id="265" r:id="rId16"/>
     <p:sldId id="266" r:id="rId17"/>
     <p:sldId id="267" r:id="rId18"/>
     <p:sldId id="268" r:id="rId19"/>
@@ -3280,819 +3279,6 @@
 </p:sld>
 </file>
 
-<file path=ppt/slides/slide10.xml><?xml version="1.0" encoding="utf-8"?>
-<p:sld xmlns:a="http://schemas.openxmlformats.org/drawingml/2006/main" xmlns:p="http://schemas.openxmlformats.org/presentationml/2006/main" xmlns:r="http://schemas.openxmlformats.org/officeDocument/2006/relationships">
-  <p:bg>
-    <p:bgPr>
-      <a:solidFill>
-        <a:srgbClr val="1A1A2E"/>
-      </a:solidFill>
-      <a:effectLst/>
-    </p:bgPr>
-  </p:bg>
-  <p:cSld>
-    <p:spTree>
-      <p:nvGrpSpPr>
-        <p:cNvPr id="1" name=""/>
-        <p:cNvGrpSpPr/>
-        <p:nvPr/>
-      </p:nvGrpSpPr>
-      <p:grpSpPr/>
-      <p:sp>
-        <p:nvSpPr>
-          <p:cNvPr id="2" name="TextBox 1"/>
-          <p:cNvSpPr txBox="1"/>
-          <p:nvPr/>
-        </p:nvSpPr>
-        <p:spPr>
-          <a:xfrm>
-            <a:off x="731520" y="365760"/>
-            <a:ext cx="10058400" cy="640080"/>
-          </a:xfrm>
-          <a:prstGeom prst="rect">
-            <a:avLst/>
-          </a:prstGeom>
-          <a:noFill/>
-        </p:spPr>
-        <p:txBody>
-          <a:bodyPr wrap="square">
-            <a:spAutoFit/>
-          </a:bodyPr>
-          <a:lstStyle/>
-          <a:p>
-            <a:pPr algn="l">
-              <a:defRPr sz="3200" b="1">
-                <a:solidFill>
-                  <a:srgbClr val="0096D6"/>
-                </a:solidFill>
-                <a:latin typeface="Calibri"/>
-              </a:defRPr>
-            </a:pPr>
-            <a:r>
-              <a:t>Example: Adding a New Field — Model &amp; Migration</a:t>
-            </a:r>
-          </a:p>
-        </p:txBody>
-      </p:sp>
-      <p:sp>
-        <p:nvSpPr>
-          <p:cNvPr id="3" name="Rounded Rectangle 2"/>
-          <p:cNvSpPr/>
-          <p:nvPr/>
-        </p:nvSpPr>
-        <p:spPr>
-          <a:xfrm>
-            <a:off x="731520" y="1280160"/>
-            <a:ext cx="5303520" cy="2926080"/>
-          </a:xfrm>
-          <a:prstGeom prst="roundRect">
-            <a:avLst/>
-          </a:prstGeom>
-          <a:solidFill>
-            <a:srgbClr val="2D2D3F"/>
-          </a:solidFill>
-          <a:ln>
-            <a:noFill/>
-          </a:ln>
-          <a:effectLst/>
-        </p:spPr>
-        <p:style>
-          <a:lnRef idx="1">
-            <a:schemeClr val="accent1"/>
-          </a:lnRef>
-          <a:fillRef idx="3">
-            <a:schemeClr val="accent1"/>
-          </a:fillRef>
-          <a:effectRef idx="2">
-            <a:schemeClr val="accent1"/>
-          </a:effectRef>
-          <a:fontRef idx="minor">
-            <a:schemeClr val="lt1"/>
-          </a:fontRef>
-        </p:style>
-        <p:txBody>
-          <a:bodyPr rtlCol="0" anchor="ctr" wrap="square" lIns="152400" rIns="152400" tIns="101600" bIns="101600"/>
-          <a:lstStyle/>
-          <a:p>
-            <a:pPr algn="ctr">
-              <a:spcBef>
-                <a:spcPts val="0"/>
-              </a:spcBef>
-              <a:spcAft>
-                <a:spcPts val="0"/>
-              </a:spcAft>
-              <a:defRPr sz="1300">
-                <a:solidFill>
-                  <a:srgbClr val="D4D4D4"/>
-                </a:solidFill>
-                <a:latin typeface="Courier New"/>
-              </a:defRPr>
-            </a:pPr>
-            <a:r>
-              <a:t># omop_core/models.py — PatientRecord class</a:t>
-            </a:r>
-          </a:p>
-          <a:p>
-            <a:pPr>
-              <a:spcBef>
-                <a:spcPts val="0"/>
-              </a:spcBef>
-              <a:spcAft>
-                <a:spcPts val="0"/>
-              </a:spcAft>
-              <a:defRPr sz="1300">
-                <a:solidFill>
-                  <a:srgbClr val="D4D4D4"/>
-                </a:solidFill>
-                <a:latin typeface="Courier New"/>
-              </a:defRPr>
-            </a:pPr>
-          </a:p>
-          <a:p>
-            <a:pPr>
-              <a:spcBef>
-                <a:spcPts val="0"/>
-              </a:spcBef>
-              <a:spcAft>
-                <a:spcPts val="0"/>
-              </a:spcAft>
-              <a:defRPr sz="1300">
-                <a:solidFill>
-                  <a:srgbClr val="D4D4D4"/>
-                </a:solidFill>
-                <a:latin typeface="Courier New"/>
-              </a:defRPr>
-            </a:pPr>
-            <a:r>
-              <a:t>class PatientRecord(models.Model):</a:t>
-            </a:r>
-          </a:p>
-          <a:p>
-            <a:pPr>
-              <a:spcBef>
-                <a:spcPts val="0"/>
-              </a:spcBef>
-              <a:spcAft>
-                <a:spcPts val="0"/>
-              </a:spcAft>
-              <a:defRPr sz="1300">
-                <a:solidFill>
-                  <a:srgbClr val="D4D4D4"/>
-                </a:solidFill>
-                <a:latin typeface="Courier New"/>
-              </a:defRPr>
-            </a:pPr>
-            <a:r>
-              <a:t>    ...</a:t>
-            </a:r>
-          </a:p>
-          <a:p>
-            <a:pPr>
-              <a:spcBef>
-                <a:spcPts val="0"/>
-              </a:spcBef>
-              <a:spcAft>
-                <a:spcPts val="0"/>
-              </a:spcAft>
-              <a:defRPr sz="1300">
-                <a:solidFill>
-                  <a:srgbClr val="D4D4D4"/>
-                </a:solidFill>
-                <a:latin typeface="Courier New"/>
-              </a:defRPr>
-            </a:pPr>
-            <a:r>
-              <a:t>    # New field: serum ferritin lab value</a:t>
-            </a:r>
-          </a:p>
-          <a:p>
-            <a:pPr>
-              <a:spcBef>
-                <a:spcPts val="0"/>
-              </a:spcBef>
-              <a:spcAft>
-                <a:spcPts val="0"/>
-              </a:spcAft>
-              <a:defRPr sz="1300">
-                <a:solidFill>
-                  <a:srgbClr val="D4D4D4"/>
-                </a:solidFill>
-                <a:latin typeface="Courier New"/>
-              </a:defRPr>
-            </a:pPr>
-            <a:r>
-              <a:t>    serum_ferritin = models.DecimalField(</a:t>
-            </a:r>
-          </a:p>
-          <a:p>
-            <a:pPr>
-              <a:spcBef>
-                <a:spcPts val="0"/>
-              </a:spcBef>
-              <a:spcAft>
-                <a:spcPts val="0"/>
-              </a:spcAft>
-              <a:defRPr sz="1300">
-                <a:solidFill>
-                  <a:srgbClr val="D4D4D4"/>
-                </a:solidFill>
-                <a:latin typeface="Courier New"/>
-              </a:defRPr>
-            </a:pPr>
-            <a:r>
-              <a:t>        max_digits=10, decimal_places=2,</a:t>
-            </a:r>
-          </a:p>
-          <a:p>
-            <a:pPr>
-              <a:spcBef>
-                <a:spcPts val="0"/>
-              </a:spcBef>
-              <a:spcAft>
-                <a:spcPts val="0"/>
-              </a:spcAft>
-              <a:defRPr sz="1300">
-                <a:solidFill>
-                  <a:srgbClr val="D4D4D4"/>
-                </a:solidFill>
-                <a:latin typeface="Courier New"/>
-              </a:defRPr>
-            </a:pPr>
-            <a:r>
-              <a:t>        blank=True, null=True,</a:t>
-            </a:r>
-          </a:p>
-          <a:p>
-            <a:pPr>
-              <a:spcBef>
-                <a:spcPts val="0"/>
-              </a:spcBef>
-              <a:spcAft>
-                <a:spcPts val="0"/>
-              </a:spcAft>
-              <a:defRPr sz="1300">
-                <a:solidFill>
-                  <a:srgbClr val="D4D4D4"/>
-                </a:solidFill>
-                <a:latin typeface="Courier New"/>
-              </a:defRPr>
-            </a:pPr>
-            <a:r>
-              <a:t>        help_text='Serum ferritin (ng/mL)'</a:t>
-            </a:r>
-          </a:p>
-          <a:p>
-            <a:pPr>
-              <a:spcBef>
-                <a:spcPts val="0"/>
-              </a:spcBef>
-              <a:spcAft>
-                <a:spcPts val="0"/>
-              </a:spcAft>
-              <a:defRPr sz="1300">
-                <a:solidFill>
-                  <a:srgbClr val="D4D4D4"/>
-                </a:solidFill>
-                <a:latin typeface="Courier New"/>
-              </a:defRPr>
-            </a:pPr>
-            <a:r>
-              <a:t>    )</a:t>
-            </a:r>
-          </a:p>
-          <a:p>
-            <a:pPr>
-              <a:spcBef>
-                <a:spcPts val="0"/>
-              </a:spcBef>
-              <a:spcAft>
-                <a:spcPts val="0"/>
-              </a:spcAft>
-              <a:defRPr sz="1300">
-                <a:solidFill>
-                  <a:srgbClr val="D4D4D4"/>
-                </a:solidFill>
-                <a:latin typeface="Courier New"/>
-              </a:defRPr>
-            </a:pPr>
-          </a:p>
-          <a:p>
-            <a:pPr>
-              <a:spcBef>
-                <a:spcPts val="0"/>
-              </a:spcBef>
-              <a:spcAft>
-                <a:spcPts val="0"/>
-              </a:spcAft>
-              <a:defRPr sz="1300">
-                <a:solidFill>
-                  <a:srgbClr val="D4D4D4"/>
-                </a:solidFill>
-                <a:latin typeface="Courier New"/>
-              </a:defRPr>
-            </a:pPr>
-            <a:r>
-              <a:t># Then generate the migration:</a:t>
-            </a:r>
-          </a:p>
-          <a:p>
-            <a:pPr>
-              <a:spcBef>
-                <a:spcPts val="0"/>
-              </a:spcBef>
-              <a:spcAft>
-                <a:spcPts val="0"/>
-              </a:spcAft>
-              <a:defRPr sz="1300">
-                <a:solidFill>
-                  <a:srgbClr val="D4D4D4"/>
-                </a:solidFill>
-                <a:latin typeface="Courier New"/>
-              </a:defRPr>
-            </a:pPr>
-            <a:r>
-              <a:t># .venv/bin/python manage.py makemigrations omop_core</a:t>
-            </a:r>
-          </a:p>
-        </p:txBody>
-      </p:sp>
-      <p:sp>
-        <p:nvSpPr>
-          <p:cNvPr id="4" name="Rounded Rectangle 3"/>
-          <p:cNvSpPr/>
-          <p:nvPr/>
-        </p:nvSpPr>
-        <p:spPr>
-          <a:xfrm>
-            <a:off x="6400800" y="1280160"/>
-            <a:ext cx="5029200" cy="2926080"/>
-          </a:xfrm>
-          <a:prstGeom prst="roundRect">
-            <a:avLst/>
-          </a:prstGeom>
-          <a:solidFill>
-            <a:srgbClr val="2D2D3F"/>
-          </a:solidFill>
-          <a:ln>
-            <a:noFill/>
-          </a:ln>
-          <a:effectLst/>
-        </p:spPr>
-        <p:style>
-          <a:lnRef idx="1">
-            <a:schemeClr val="accent1"/>
-          </a:lnRef>
-          <a:fillRef idx="3">
-            <a:schemeClr val="accent1"/>
-          </a:fillRef>
-          <a:effectRef idx="2">
-            <a:schemeClr val="accent1"/>
-          </a:effectRef>
-          <a:fontRef idx="minor">
-            <a:schemeClr val="lt1"/>
-          </a:fontRef>
-        </p:style>
-        <p:txBody>
-          <a:bodyPr rtlCol="0" anchor="ctr" wrap="square" lIns="152400" rIns="152400" tIns="101600" bIns="101600"/>
-          <a:lstStyle/>
-          <a:p>
-            <a:pPr algn="ctr">
-              <a:spcBef>
-                <a:spcPts val="0"/>
-              </a:spcBef>
-              <a:spcAft>
-                <a:spcPts val="0"/>
-              </a:spcAft>
-              <a:defRPr sz="1300">
-                <a:solidFill>
-                  <a:srgbClr val="D4D4D4"/>
-                </a:solidFill>
-                <a:latin typeface="Courier New"/>
-              </a:defRPr>
-            </a:pPr>
-            <a:r>
-              <a:t># frontend/src/types/patient.ts</a:t>
-            </a:r>
-          </a:p>
-          <a:p>
-            <a:pPr>
-              <a:spcBef>
-                <a:spcPts val="0"/>
-              </a:spcBef>
-              <a:spcAft>
-                <a:spcPts val="0"/>
-              </a:spcAft>
-              <a:defRPr sz="1300">
-                <a:solidFill>
-                  <a:srgbClr val="D4D4D4"/>
-                </a:solidFill>
-                <a:latin typeface="Courier New"/>
-              </a:defRPr>
-            </a:pPr>
-          </a:p>
-          <a:p>
-            <a:pPr>
-              <a:spcBef>
-                <a:spcPts val="0"/>
-              </a:spcBef>
-              <a:spcAft>
-                <a:spcPts val="0"/>
-              </a:spcAft>
-              <a:defRPr sz="1300">
-                <a:solidFill>
-                  <a:srgbClr val="D4D4D4"/>
-                </a:solidFill>
-                <a:latin typeface="Courier New"/>
-              </a:defRPr>
-            </a:pPr>
-            <a:r>
-              <a:t>export interface PatientInfo {</a:t>
-            </a:r>
-          </a:p>
-          <a:p>
-            <a:pPr>
-              <a:spcBef>
-                <a:spcPts val="0"/>
-              </a:spcBef>
-              <a:spcAft>
-                <a:spcPts val="0"/>
-              </a:spcAft>
-              <a:defRPr sz="1300">
-                <a:solidFill>
-                  <a:srgbClr val="D4D4D4"/>
-                </a:solidFill>
-                <a:latin typeface="Courier New"/>
-              </a:defRPr>
-            </a:pPr>
-            <a:r>
-              <a:t>    ...</a:t>
-            </a:r>
-          </a:p>
-          <a:p>
-            <a:pPr>
-              <a:spcBef>
-                <a:spcPts val="0"/>
-              </a:spcBef>
-              <a:spcAft>
-                <a:spcPts val="0"/>
-              </a:spcAft>
-              <a:defRPr sz="1300">
-                <a:solidFill>
-                  <a:srgbClr val="D4D4D4"/>
-                </a:solidFill>
-                <a:latin typeface="Courier New"/>
-              </a:defRPr>
-            </a:pPr>
-            <a:r>
-              <a:t>    // Labs</a:t>
-            </a:r>
-          </a:p>
-          <a:p>
-            <a:pPr>
-              <a:spcBef>
-                <a:spcPts val="0"/>
-              </a:spcBef>
-              <a:spcAft>
-                <a:spcPts val="0"/>
-              </a:spcAft>
-              <a:defRPr sz="1300">
-                <a:solidFill>
-                  <a:srgbClr val="D4D4D4"/>
-                </a:solidFill>
-                <a:latin typeface="Courier New"/>
-              </a:defRPr>
-            </a:pPr>
-            <a:r>
-              <a:t>    serum_ferritin?: number;  // ng/mL</a:t>
-            </a:r>
-          </a:p>
-          <a:p>
-            <a:pPr>
-              <a:spcBef>
-                <a:spcPts val="0"/>
-              </a:spcBef>
-              <a:spcAft>
-                <a:spcPts val="0"/>
-              </a:spcAft>
-              <a:defRPr sz="1300">
-                <a:solidFill>
-                  <a:srgbClr val="D4D4D4"/>
-                </a:solidFill>
-                <a:latin typeface="Courier New"/>
-              </a:defRPr>
-            </a:pPr>
-            <a:r>
-              <a:t>    ...</a:t>
-            </a:r>
-          </a:p>
-          <a:p>
-            <a:pPr>
-              <a:spcBef>
-                <a:spcPts val="0"/>
-              </a:spcBef>
-              <a:spcAft>
-                <a:spcPts val="0"/>
-              </a:spcAft>
-              <a:defRPr sz="1300">
-                <a:solidFill>
-                  <a:srgbClr val="D4D4D4"/>
-                </a:solidFill>
-                <a:latin typeface="Courier New"/>
-              </a:defRPr>
-            </a:pPr>
-            <a:r>
-              <a:t>}</a:t>
-            </a:r>
-          </a:p>
-          <a:p>
-            <a:pPr>
-              <a:spcBef>
-                <a:spcPts val="0"/>
-              </a:spcBef>
-              <a:spcAft>
-                <a:spcPts val="0"/>
-              </a:spcAft>
-              <a:defRPr sz="1300">
-                <a:solidFill>
-                  <a:srgbClr val="D4D4D4"/>
-                </a:solidFill>
-                <a:latin typeface="Courier New"/>
-              </a:defRPr>
-            </a:pPr>
-          </a:p>
-          <a:p>
-            <a:pPr>
-              <a:spcBef>
-                <a:spcPts val="0"/>
-              </a:spcBef>
-              <a:spcAft>
-                <a:spcPts val="0"/>
-              </a:spcAft>
-              <a:defRPr sz="1300">
-                <a:solidFill>
-                  <a:srgbClr val="D4D4D4"/>
-                </a:solidFill>
-                <a:latin typeface="Courier New"/>
-              </a:defRPr>
-            </a:pPr>
-            <a:r>
-              <a:t># patient_portal/api/serializers.py</a:t>
-            </a:r>
-          </a:p>
-          <a:p>
-            <a:pPr>
-              <a:spcBef>
-                <a:spcPts val="0"/>
-              </a:spcBef>
-              <a:spcAft>
-                <a:spcPts val="0"/>
-              </a:spcAft>
-              <a:defRPr sz="1300">
-                <a:solidFill>
-                  <a:srgbClr val="D4D4D4"/>
-                </a:solidFill>
-                <a:latin typeface="Courier New"/>
-              </a:defRPr>
-            </a:pPr>
-            <a:r>
-              <a:t># fields = '__all__' auto-includes it</a:t>
-            </a:r>
-          </a:p>
-          <a:p>
-            <a:pPr>
-              <a:spcBef>
-                <a:spcPts val="0"/>
-              </a:spcBef>
-              <a:spcAft>
-                <a:spcPts val="0"/>
-              </a:spcAft>
-              <a:defRPr sz="1300">
-                <a:solidFill>
-                  <a:srgbClr val="D4D4D4"/>
-                </a:solidFill>
-                <a:latin typeface="Courier New"/>
-              </a:defRPr>
-            </a:pPr>
-            <a:r>
-              <a:t># Add to read_only_fields if OMOP-derived:</a:t>
-            </a:r>
-          </a:p>
-          <a:p>
-            <a:pPr>
-              <a:spcBef>
-                <a:spcPts val="0"/>
-              </a:spcBef>
-              <a:spcAft>
-                <a:spcPts val="0"/>
-              </a:spcAft>
-              <a:defRPr sz="1300">
-                <a:solidFill>
-                  <a:srgbClr val="D4D4D4"/>
-                </a:solidFill>
-                <a:latin typeface="Courier New"/>
-              </a:defRPr>
-            </a:pPr>
-            <a:r>
-              <a:t>#   *PATIENT_RECORD_OMOP_MAPPED_FIELDS,</a:t>
-            </a:r>
-          </a:p>
-        </p:txBody>
-      </p:sp>
-      <p:sp>
-        <p:nvSpPr>
-          <p:cNvPr id="5" name="Rounded Rectangle 4"/>
-          <p:cNvSpPr/>
-          <p:nvPr/>
-        </p:nvSpPr>
-        <p:spPr>
-          <a:xfrm>
-            <a:off x="731520" y="4572000"/>
-            <a:ext cx="10698480" cy="1828800"/>
-          </a:xfrm>
-          <a:prstGeom prst="roundRect">
-            <a:avLst/>
-          </a:prstGeom>
-          <a:solidFill>
-            <a:srgbClr val="2D2D3F"/>
-          </a:solidFill>
-          <a:ln>
-            <a:noFill/>
-          </a:ln>
-          <a:effectLst/>
-        </p:spPr>
-        <p:style>
-          <a:lnRef idx="1">
-            <a:schemeClr val="accent1"/>
-          </a:lnRef>
-          <a:fillRef idx="3">
-            <a:schemeClr val="accent1"/>
-          </a:fillRef>
-          <a:effectRef idx="2">
-            <a:schemeClr val="accent1"/>
-          </a:effectRef>
-          <a:fontRef idx="minor">
-            <a:schemeClr val="lt1"/>
-          </a:fontRef>
-        </p:style>
-        <p:txBody>
-          <a:bodyPr rtlCol="0" anchor="ctr" wrap="square" lIns="152400" rIns="152400" tIns="101600" bIns="101600"/>
-          <a:lstStyle/>
-          <a:p>
-            <a:pPr algn="ctr">
-              <a:spcBef>
-                <a:spcPts val="0"/>
-              </a:spcBef>
-              <a:spcAft>
-                <a:spcPts val="0"/>
-              </a:spcAft>
-              <a:defRPr sz="1300">
-                <a:solidFill>
-                  <a:srgbClr val="D4D4D4"/>
-                </a:solidFill>
-                <a:latin typeface="Courier New"/>
-              </a:defRPr>
-            </a:pPr>
-            <a:r>
-              <a:t># React UI — LabsTab.tsx</a:t>
-            </a:r>
-          </a:p>
-          <a:p>
-            <a:pPr>
-              <a:spcBef>
-                <a:spcPts val="0"/>
-              </a:spcBef>
-              <a:spcAft>
-                <a:spcPts val="0"/>
-              </a:spcAft>
-              <a:defRPr sz="1300">
-                <a:solidFill>
-                  <a:srgbClr val="D4D4D4"/>
-                </a:solidFill>
-                <a:latin typeface="Courier New"/>
-              </a:defRPr>
-            </a:pPr>
-          </a:p>
-          <a:p>
-            <a:pPr>
-              <a:spcBef>
-                <a:spcPts val="0"/>
-              </a:spcBef>
-              <a:spcAft>
-                <a:spcPts val="0"/>
-              </a:spcAft>
-              <a:defRPr sz="1300">
-                <a:solidFill>
-                  <a:srgbClr val="D4D4D4"/>
-                </a:solidFill>
-                <a:latin typeface="Courier New"/>
-              </a:defRPr>
-            </a:pPr>
-            <a:r>
-              <a:t>&lt;Field label="Serum Ferritin (ng/mL)" name="serum_ferritin" type="number"</a:t>
-            </a:r>
-          </a:p>
-          <a:p>
-            <a:pPr>
-              <a:spcBef>
-                <a:spcPts val="0"/>
-              </a:spcBef>
-              <a:spcAft>
-                <a:spcPts val="0"/>
-              </a:spcAft>
-              <a:defRPr sz="1300">
-                <a:solidFill>
-                  <a:srgbClr val="D4D4D4"/>
-                </a:solidFill>
-                <a:latin typeface="Courier New"/>
-              </a:defRPr>
-            </a:pPr>
-            <a:r>
-              <a:t>  value={formData?.serum_ferritin} onChange={onChange} /&gt;</a:t>
-            </a:r>
-          </a:p>
-          <a:p>
-            <a:pPr>
-              <a:spcBef>
-                <a:spcPts val="0"/>
-              </a:spcBef>
-              <a:spcAft>
-                <a:spcPts val="0"/>
-              </a:spcAft>
-              <a:defRPr sz="1300">
-                <a:solidFill>
-                  <a:srgbClr val="D4D4D4"/>
-                </a:solidFill>
-                <a:latin typeface="Courier New"/>
-              </a:defRPr>
-            </a:pPr>
-          </a:p>
-          <a:p>
-            <a:pPr>
-              <a:spcBef>
-                <a:spcPts val="0"/>
-              </a:spcBef>
-              <a:spcAft>
-                <a:spcPts val="0"/>
-              </a:spcAft>
-              <a:defRPr sz="1300">
-                <a:solidFill>
-                  <a:srgbClr val="D4D4D4"/>
-                </a:solidFill>
-                <a:latin typeface="Courier New"/>
-              </a:defRPr>
-            </a:pPr>
-            <a:r>
-              <a:t># Apply migration to staging, then local:</a:t>
-            </a:r>
-          </a:p>
-          <a:p>
-            <a:pPr>
-              <a:spcBef>
-                <a:spcPts val="0"/>
-              </a:spcBef>
-              <a:spcAft>
-                <a:spcPts val="0"/>
-              </a:spcAft>
-              <a:defRPr sz="1300">
-                <a:solidFill>
-                  <a:srgbClr val="D4D4D4"/>
-                </a:solidFill>
-                <a:latin typeface="Courier New"/>
-              </a:defRPr>
-            </a:pPr>
-            <a:r>
-              <a:t>DATABASE_URL="$STAGING_DATABASE_URL" .venv/bin/python manage.py migrate</a:t>
-            </a:r>
-          </a:p>
-          <a:p>
-            <a:pPr>
-              <a:spcBef>
-                <a:spcPts val="0"/>
-              </a:spcBef>
-              <a:spcAft>
-                <a:spcPts val="0"/>
-              </a:spcAft>
-              <a:defRPr sz="1300">
-                <a:solidFill>
-                  <a:srgbClr val="D4D4D4"/>
-                </a:solidFill>
-                <a:latin typeface="Courier New"/>
-              </a:defRPr>
-            </a:pPr>
-            <a:r>
-              <a:t>DATABASE_URL="postgresql://postgres@localhost:5432/promop_dev" .venv/bin/python manage.py migrate</a:t>
-            </a:r>
-          </a:p>
-        </p:txBody>
-      </p:sp>
-    </p:spTree>
-  </p:cSld>
-  <p:clrMapOvr>
-    <a:masterClrMapping/>
-  </p:clrMapOvr>
-</p:sld>
-</file>
-
 <file path=ppt/slides/slide11.xml><?xml version="1.0" encoding="utf-8"?>
 <p:sld xmlns:a="http://schemas.openxmlformats.org/drawingml/2006/main" xmlns:p="http://schemas.openxmlformats.org/presentationml/2006/main" xmlns:r="http://schemas.openxmlformats.org/officeDocument/2006/relationships">
   <p:bg>
@@ -23168,8 +22354,8 @@
         </p:nvSpPr>
         <p:spPr>
           <a:xfrm>
-            <a:off x="731520" y="365760"/>
-            <a:ext cx="10058400" cy="640080"/>
+            <a:off x="548640" y="320040"/>
+            <a:ext cx="11064240" cy="502920"/>
           </a:xfrm>
           <a:prstGeom prst="rect">
             <a:avLst/>
@@ -23182,16 +22368,16 @@
           </a:bodyPr>
           <a:lstStyle/>
           <a:p>
-            <a:pPr algn="l">
-              <a:defRPr sz="3200" b="1">
-                <a:solidFill>
-                  <a:srgbClr val="0096D6"/>
-                </a:solidFill>
-                <a:latin typeface="Calibri"/>
-              </a:defRPr>
-            </a:pPr>
-            <a:r>
-              <a:t>Adding a New Patient Attribute — Checklist</a:t>
+            <a:pPr>
+              <a:defRPr sz="2900" b="1">
+                <a:solidFill>
+                  <a:srgbClr val="F8FAFC"/>
+                </a:solidFill>
+                <a:latin typeface="Aptos"/>
+              </a:defRPr>
+            </a:pPr>
+            <a:r>
+              <a:t>Add and Map Fields in the Field Mappings UI</a:t>
             </a:r>
           </a:p>
         </p:txBody>
@@ -23204,8 +22390,8 @@
         </p:nvSpPr>
         <p:spPr>
           <a:xfrm>
-            <a:off x="731520" y="1188720"/>
-            <a:ext cx="10058400" cy="457200"/>
+            <a:off x="548640" y="896112"/>
+            <a:ext cx="10972800" cy="438912"/>
           </a:xfrm>
           <a:prstGeom prst="rect">
             <a:avLst/>
@@ -23218,39 +22404,41 @@
           </a:bodyPr>
           <a:lstStyle/>
           <a:p>
-            <a:pPr algn="l">
-              <a:defRPr sz="1600" b="0">
-                <a:solidFill>
-                  <a:srgbClr val="BBBBBB"/>
-                </a:solidFill>
-                <a:latin typeface="Calibri"/>
-              </a:defRPr>
-            </a:pPr>
-            <a:r>
-              <a:t>Every new field must touch ALL of these layers (see CLAUDE.md for full details)</a:t>
+            <a:pPr>
+              <a:defRPr sz="1500" b="0">
+                <a:solidFill>
+                  <a:srgbClr val="CBD5E1"/>
+                </a:solidFill>
+                <a:latin typeface="Aptos"/>
+              </a:defRPr>
+            </a:pPr>
+            <a:r>
+              <a:t>Administrators can create a runtime patient field and its approved OMOP mapping together — no model, migration, serializer, or frontend change required.</a:t>
             </a:r>
           </a:p>
         </p:txBody>
       </p:sp>
       <p:sp>
         <p:nvSpPr>
-          <p:cNvPr id="4" name="Oval 3"/>
+          <p:cNvPr id="4" name="Rounded Rectangle 3"/>
           <p:cNvSpPr/>
           <p:nvPr/>
         </p:nvSpPr>
         <p:spPr>
           <a:xfrm>
-            <a:off x="777240" y="1854200"/>
-            <a:ext cx="320040" cy="320040"/>
+            <a:off x="548640" y="1417320"/>
+            <a:ext cx="5440680" cy="640080"/>
           </a:xfrm>
-          <a:prstGeom prst="ellipse">
+          <a:prstGeom prst="roundRect">
             <a:avLst/>
           </a:prstGeom>
           <a:solidFill>
-            <a:srgbClr val="0096D6"/>
+            <a:srgbClr val="E8F1FF"/>
           </a:solidFill>
           <a:ln>
-            <a:noFill/>
+            <a:solidFill>
+              <a:srgbClr val="A7C9F2"/>
+            </a:solidFill>
           </a:ln>
         </p:spPr>
         <p:style>
@@ -23271,7 +22459,17 @@
           <a:bodyPr rtlCol="0" anchor="ctr"/>
           <a:lstStyle/>
           <a:p>
-            <a:pPr algn="ctr"/>
+            <a:pPr algn="ctr">
+              <a:defRPr sz="1500" b="1">
+                <a:solidFill>
+                  <a:srgbClr val="1E5AA0"/>
+                </a:solidFill>
+                <a:latin typeface="Aptos"/>
+              </a:defRPr>
+            </a:pPr>
+            <a:r>
+              <a:t>Field Mappings is the curation layer between a patient field and the OMOP fact that supplies it.</a:t>
+            </a:r>
           </a:p>
         </p:txBody>
       </p:sp>
@@ -23283,8 +22481,8 @@
         </p:nvSpPr>
         <p:spPr>
           <a:xfrm>
-            <a:off x="731520" y="1854200"/>
-            <a:ext cx="411480" cy="320040"/>
+            <a:off x="640080" y="2286000"/>
+            <a:ext cx="5394960" cy="3108960"/>
           </a:xfrm>
           <a:prstGeom prst="rect">
             <a:avLst/>
@@ -23297,30 +22495,105 @@
           </a:bodyPr>
           <a:lstStyle/>
           <a:p>
-            <a:pPr algn="ctr">
-              <a:defRPr sz="1400" b="1">
-                <a:solidFill>
-                  <a:srgbClr val="FFFFFF"/>
-                </a:solidFill>
-                <a:latin typeface="Calibri"/>
-              </a:defRPr>
-            </a:pPr>
-            <a:r>
-              <a:t>1</a:t>
+            <a:pPr>
+              <a:spcAft>
+                <a:spcPts val="1200"/>
+              </a:spcAft>
+              <a:defRPr sz="1900">
+                <a:solidFill>
+                  <a:srgbClr val="E2E8F0"/>
+                </a:solidFill>
+                <a:latin typeface="Aptos"/>
+              </a:defRPr>
+            </a:pPr>
+            <a:r>
+              <a:t>Define the field name, type, and patient-view tab.</a:t>
+            </a:r>
+          </a:p>
+          <a:p>
+            <a:pPr>
+              <a:spcAft>
+                <a:spcPts val="1200"/>
+              </a:spcAft>
+              <a:defRPr sz="1900">
+                <a:solidFill>
+                  <a:srgbClr val="E2E8F0"/>
+                </a:solidFill>
+                <a:latin typeface="Aptos"/>
+              </a:defRPr>
+            </a:pPr>
+            <a:r>
+              <a:t>Search the loaded vocabulary and select the clinical concept.</a:t>
+            </a:r>
+          </a:p>
+          <a:p>
+            <a:pPr>
+              <a:spcAft>
+                <a:spcPts val="1200"/>
+              </a:spcAft>
+              <a:defRPr sz="1900">
+                <a:solidFill>
+                  <a:srgbClr val="E2E8F0"/>
+                </a:solidFill>
+                <a:latin typeface="Aptos"/>
+              </a:defRPr>
+            </a:pPr>
+            <a:r>
+              <a:t>Set the OMOP table, source value, and unit where applicable.</a:t>
+            </a:r>
+          </a:p>
+          <a:p>
+            <a:pPr>
+              <a:spcAft>
+                <a:spcPts val="1200"/>
+              </a:spcAft>
+              <a:defRPr sz="1900">
+                <a:solidFill>
+                  <a:srgbClr val="E2E8F0"/>
+                </a:solidFill>
+                <a:latin typeface="Aptos"/>
+              </a:defRPr>
+            </a:pPr>
+            <a:r>
+              <a:t>Approve the mapping to make the field available for structured writes.</a:t>
             </a:r>
           </a:p>
         </p:txBody>
       </p:sp>
+      <p:pic>
+        <p:nvPicPr>
+          <p:cNvPr id="6" name="Picture 5" descr="concept_mappings.png"/>
+          <p:cNvPicPr>
+            <a:picLocks noChangeAspect="1"/>
+          </p:cNvPicPr>
+          <p:nvPr/>
+        </p:nvPicPr>
+        <p:blipFill>
+          <a:blip r:embed="rId2"/>
+          <a:stretch>
+            <a:fillRect/>
+          </a:stretch>
+        </p:blipFill>
+        <p:spPr>
+          <a:xfrm>
+            <a:off x="6400800" y="1417320"/>
+            <a:ext cx="5257800" cy="4983480"/>
+          </a:xfrm>
+          <a:prstGeom prst="rect">
+            <a:avLst/>
+          </a:prstGeom>
+        </p:spPr>
+      </p:pic>
       <p:sp>
         <p:nvSpPr>
-          <p:cNvPr id="6" name="TextBox 5"/>
+          <p:cNvPr id="7" name="TextBox 6"/>
           <p:cNvSpPr txBox="1"/>
           <p:nvPr/>
         </p:nvSpPr>
         <p:spPr>
           <a:xfrm>
-            <a:off x="1371600" y="1828800"/>
-            <a:ext cx="2926080" cy="320040"/>
+            <a:off x="640080" y="5650992"/>
+            <a:ext cx="5440680" cy="438912"/>
           </a:xfrm>
           <a:prstGeom prst="rect">
             <a:avLst/>
@@ -23333,1260 +22606,16 @@
           </a:bodyPr>
           <a:lstStyle/>
           <a:p>
-            <a:pPr algn="l">
-              <a:defRPr sz="1600" b="1">
-                <a:solidFill>
-                  <a:srgbClr val="FFFFFF"/>
-                </a:solidFill>
-                <a:latin typeface="Calibri"/>
-              </a:defRPr>
-            </a:pPr>
-            <a:r>
-              <a:t>Django Model</a:t>
-            </a:r>
-          </a:p>
-        </p:txBody>
-      </p:sp>
-      <p:sp>
-        <p:nvSpPr>
-          <p:cNvPr id="7" name="TextBox 6"/>
-          <p:cNvSpPr txBox="1"/>
-          <p:nvPr/>
-        </p:nvSpPr>
-        <p:spPr>
-          <a:xfrm>
-            <a:off x="4389120" y="1828800"/>
-            <a:ext cx="7040880" cy="320040"/>
-          </a:xfrm>
-          <a:prstGeom prst="rect">
-            <a:avLst/>
-          </a:prstGeom>
-          <a:noFill/>
-        </p:spPr>
-        <p:txBody>
-          <a:bodyPr wrap="square">
-            <a:spAutoFit/>
-          </a:bodyPr>
-          <a:lstStyle/>
-          <a:p>
-            <a:pPr algn="l">
-              <a:defRPr sz="1400" b="0">
-                <a:solidFill>
-                  <a:srgbClr val="E8E8E8"/>
-                </a:solidFill>
-                <a:latin typeface="Calibri"/>
-              </a:defRPr>
-            </a:pPr>
-            <a:r>
-              <a:t>omop_core/models.py — add field to PatientRecord</a:t>
-            </a:r>
-          </a:p>
-        </p:txBody>
-      </p:sp>
-      <p:sp>
-        <p:nvSpPr>
-          <p:cNvPr id="8" name="Oval 7"/>
-          <p:cNvSpPr/>
-          <p:nvPr/>
-        </p:nvSpPr>
-        <p:spPr>
-          <a:xfrm>
-            <a:off x="777240" y="2311400"/>
-            <a:ext cx="320040" cy="320040"/>
-          </a:xfrm>
-          <a:prstGeom prst="ellipse">
-            <a:avLst/>
-          </a:prstGeom>
-          <a:solidFill>
-            <a:srgbClr val="0096D6"/>
-          </a:solidFill>
-          <a:ln>
-            <a:noFill/>
-          </a:ln>
-        </p:spPr>
-        <p:style>
-          <a:lnRef idx="1">
-            <a:schemeClr val="accent1"/>
-          </a:lnRef>
-          <a:fillRef idx="3">
-            <a:schemeClr val="accent1"/>
-          </a:fillRef>
-          <a:effectRef idx="2">
-            <a:schemeClr val="accent1"/>
-          </a:effectRef>
-          <a:fontRef idx="minor">
-            <a:schemeClr val="lt1"/>
-          </a:fontRef>
-        </p:style>
-        <p:txBody>
-          <a:bodyPr rtlCol="0" anchor="ctr"/>
-          <a:lstStyle/>
-          <a:p>
-            <a:pPr algn="ctr"/>
-          </a:p>
-        </p:txBody>
-      </p:sp>
-      <p:sp>
-        <p:nvSpPr>
-          <p:cNvPr id="9" name="TextBox 8"/>
-          <p:cNvSpPr txBox="1"/>
-          <p:nvPr/>
-        </p:nvSpPr>
-        <p:spPr>
-          <a:xfrm>
-            <a:off x="731520" y="2311400"/>
-            <a:ext cx="411480" cy="320040"/>
-          </a:xfrm>
-          <a:prstGeom prst="rect">
-            <a:avLst/>
-          </a:prstGeom>
-          <a:noFill/>
-        </p:spPr>
-        <p:txBody>
-          <a:bodyPr wrap="square">
-            <a:spAutoFit/>
-          </a:bodyPr>
-          <a:lstStyle/>
-          <a:p>
-            <a:pPr algn="ctr">
-              <a:defRPr sz="1400" b="1">
-                <a:solidFill>
-                  <a:srgbClr val="FFFFFF"/>
-                </a:solidFill>
-                <a:latin typeface="Calibri"/>
-              </a:defRPr>
-            </a:pPr>
-            <a:r>
-              <a:t>2</a:t>
-            </a:r>
-          </a:p>
-        </p:txBody>
-      </p:sp>
-      <p:sp>
-        <p:nvSpPr>
-          <p:cNvPr id="10" name="TextBox 9"/>
-          <p:cNvSpPr txBox="1"/>
-          <p:nvPr/>
-        </p:nvSpPr>
-        <p:spPr>
-          <a:xfrm>
-            <a:off x="1371600" y="2286000"/>
-            <a:ext cx="2926080" cy="320040"/>
-          </a:xfrm>
-          <a:prstGeom prst="rect">
-            <a:avLst/>
-          </a:prstGeom>
-          <a:noFill/>
-        </p:spPr>
-        <p:txBody>
-          <a:bodyPr wrap="square">
-            <a:spAutoFit/>
-          </a:bodyPr>
-          <a:lstStyle/>
-          <a:p>
-            <a:pPr algn="l">
-              <a:defRPr sz="1600" b="1">
-                <a:solidFill>
-                  <a:srgbClr val="FFFFFF"/>
-                </a:solidFill>
-                <a:latin typeface="Calibri"/>
-              </a:defRPr>
-            </a:pPr>
-            <a:r>
-              <a:t>DB Migration</a:t>
-            </a:r>
-          </a:p>
-        </p:txBody>
-      </p:sp>
-      <p:sp>
-        <p:nvSpPr>
-          <p:cNvPr id="11" name="TextBox 10"/>
-          <p:cNvSpPr txBox="1"/>
-          <p:nvPr/>
-        </p:nvSpPr>
-        <p:spPr>
-          <a:xfrm>
-            <a:off x="4389120" y="2286000"/>
-            <a:ext cx="7040880" cy="320040"/>
-          </a:xfrm>
-          <a:prstGeom prst="rect">
-            <a:avLst/>
-          </a:prstGeom>
-          <a:noFill/>
-        </p:spPr>
-        <p:txBody>
-          <a:bodyPr wrap="square">
-            <a:spAutoFit/>
-          </a:bodyPr>
-          <a:lstStyle/>
-          <a:p>
-            <a:pPr algn="l">
-              <a:defRPr sz="1400" b="0">
-                <a:solidFill>
-                  <a:srgbClr val="E8E8E8"/>
-                </a:solidFill>
-                <a:latin typeface="Calibri"/>
-              </a:defRPr>
-            </a:pPr>
-            <a:r>
-              <a:t>makemigrations + migrate to staging</a:t>
-            </a:r>
-          </a:p>
-        </p:txBody>
-      </p:sp>
-      <p:sp>
-        <p:nvSpPr>
-          <p:cNvPr id="12" name="Oval 11"/>
-          <p:cNvSpPr/>
-          <p:nvPr/>
-        </p:nvSpPr>
-        <p:spPr>
-          <a:xfrm>
-            <a:off x="777240" y="2768600"/>
-            <a:ext cx="320040" cy="320040"/>
-          </a:xfrm>
-          <a:prstGeom prst="ellipse">
-            <a:avLst/>
-          </a:prstGeom>
-          <a:solidFill>
-            <a:srgbClr val="0096D6"/>
-          </a:solidFill>
-          <a:ln>
-            <a:noFill/>
-          </a:ln>
-        </p:spPr>
-        <p:style>
-          <a:lnRef idx="1">
-            <a:schemeClr val="accent1"/>
-          </a:lnRef>
-          <a:fillRef idx="3">
-            <a:schemeClr val="accent1"/>
-          </a:fillRef>
-          <a:effectRef idx="2">
-            <a:schemeClr val="accent1"/>
-          </a:effectRef>
-          <a:fontRef idx="minor">
-            <a:schemeClr val="lt1"/>
-          </a:fontRef>
-        </p:style>
-        <p:txBody>
-          <a:bodyPr rtlCol="0" anchor="ctr"/>
-          <a:lstStyle/>
-          <a:p>
-            <a:pPr algn="ctr"/>
-          </a:p>
-        </p:txBody>
-      </p:sp>
-      <p:sp>
-        <p:nvSpPr>
-          <p:cNvPr id="13" name="TextBox 12"/>
-          <p:cNvSpPr txBox="1"/>
-          <p:nvPr/>
-        </p:nvSpPr>
-        <p:spPr>
-          <a:xfrm>
-            <a:off x="731520" y="2768600"/>
-            <a:ext cx="411480" cy="320040"/>
-          </a:xfrm>
-          <a:prstGeom prst="rect">
-            <a:avLst/>
-          </a:prstGeom>
-          <a:noFill/>
-        </p:spPr>
-        <p:txBody>
-          <a:bodyPr wrap="square">
-            <a:spAutoFit/>
-          </a:bodyPr>
-          <a:lstStyle/>
-          <a:p>
-            <a:pPr algn="ctr">
-              <a:defRPr sz="1400" b="1">
-                <a:solidFill>
-                  <a:srgbClr val="FFFFFF"/>
-                </a:solidFill>
-                <a:latin typeface="Calibri"/>
-              </a:defRPr>
-            </a:pPr>
-            <a:r>
-              <a:t>3</a:t>
-            </a:r>
-          </a:p>
-        </p:txBody>
-      </p:sp>
-      <p:sp>
-        <p:nvSpPr>
-          <p:cNvPr id="14" name="TextBox 13"/>
-          <p:cNvSpPr txBox="1"/>
-          <p:nvPr/>
-        </p:nvSpPr>
-        <p:spPr>
-          <a:xfrm>
-            <a:off x="1371600" y="2743200"/>
-            <a:ext cx="2926080" cy="320040"/>
-          </a:xfrm>
-          <a:prstGeom prst="rect">
-            <a:avLst/>
-          </a:prstGeom>
-          <a:noFill/>
-        </p:spPr>
-        <p:txBody>
-          <a:bodyPr wrap="square">
-            <a:spAutoFit/>
-          </a:bodyPr>
-          <a:lstStyle/>
-          <a:p>
-            <a:pPr algn="l">
-              <a:defRPr sz="1600" b="1">
-                <a:solidFill>
-                  <a:srgbClr val="FFFFFF"/>
-                </a:solidFill>
-                <a:latin typeface="Calibri"/>
-              </a:defRPr>
-            </a:pPr>
-            <a:r>
-              <a:t>DRF Serializer</a:t>
-            </a:r>
-          </a:p>
-        </p:txBody>
-      </p:sp>
-      <p:sp>
-        <p:nvSpPr>
-          <p:cNvPr id="15" name="TextBox 14"/>
-          <p:cNvSpPr txBox="1"/>
-          <p:nvPr/>
-        </p:nvSpPr>
-        <p:spPr>
-          <a:xfrm>
-            <a:off x="4389120" y="2743200"/>
-            <a:ext cx="7040880" cy="320040"/>
-          </a:xfrm>
-          <a:prstGeom prst="rect">
-            <a:avLst/>
-          </a:prstGeom>
-          <a:noFill/>
-        </p:spPr>
-        <p:txBody>
-          <a:bodyPr wrap="square">
-            <a:spAutoFit/>
-          </a:bodyPr>
-          <a:lstStyle/>
-          <a:p>
-            <a:pPr algn="l">
-              <a:defRPr sz="1400" b="0">
-                <a:solidFill>
-                  <a:srgbClr val="E8E8E8"/>
-                </a:solidFill>
-                <a:latin typeface="Calibri"/>
-              </a:defRPr>
-            </a:pPr>
-            <a:r>
-              <a:t>Auto-included via fields='__all__' — add custom logic if needed</a:t>
-            </a:r>
-          </a:p>
-        </p:txBody>
-      </p:sp>
-      <p:sp>
-        <p:nvSpPr>
-          <p:cNvPr id="16" name="Oval 15"/>
-          <p:cNvSpPr/>
-          <p:nvPr/>
-        </p:nvSpPr>
-        <p:spPr>
-          <a:xfrm>
-            <a:off x="777240" y="3225800"/>
-            <a:ext cx="320040" cy="320040"/>
-          </a:xfrm>
-          <a:prstGeom prst="ellipse">
-            <a:avLst/>
-          </a:prstGeom>
-          <a:solidFill>
-            <a:srgbClr val="0096D6"/>
-          </a:solidFill>
-          <a:ln>
-            <a:noFill/>
-          </a:ln>
-        </p:spPr>
-        <p:style>
-          <a:lnRef idx="1">
-            <a:schemeClr val="accent1"/>
-          </a:lnRef>
-          <a:fillRef idx="3">
-            <a:schemeClr val="accent1"/>
-          </a:fillRef>
-          <a:effectRef idx="2">
-            <a:schemeClr val="accent1"/>
-          </a:effectRef>
-          <a:fontRef idx="minor">
-            <a:schemeClr val="lt1"/>
-          </a:fontRef>
-        </p:style>
-        <p:txBody>
-          <a:bodyPr rtlCol="0" anchor="ctr"/>
-          <a:lstStyle/>
-          <a:p>
-            <a:pPr algn="ctr"/>
-          </a:p>
-        </p:txBody>
-      </p:sp>
-      <p:sp>
-        <p:nvSpPr>
-          <p:cNvPr id="17" name="TextBox 16"/>
-          <p:cNvSpPr txBox="1"/>
-          <p:nvPr/>
-        </p:nvSpPr>
-        <p:spPr>
-          <a:xfrm>
-            <a:off x="731520" y="3225800"/>
-            <a:ext cx="411480" cy="320040"/>
-          </a:xfrm>
-          <a:prstGeom prst="rect">
-            <a:avLst/>
-          </a:prstGeom>
-          <a:noFill/>
-        </p:spPr>
-        <p:txBody>
-          <a:bodyPr wrap="square">
-            <a:spAutoFit/>
-          </a:bodyPr>
-          <a:lstStyle/>
-          <a:p>
-            <a:pPr algn="ctr">
-              <a:defRPr sz="1400" b="1">
-                <a:solidFill>
-                  <a:srgbClr val="FFFFFF"/>
-                </a:solidFill>
-                <a:latin typeface="Calibri"/>
-              </a:defRPr>
-            </a:pPr>
-            <a:r>
-              <a:t>4</a:t>
-            </a:r>
-          </a:p>
-        </p:txBody>
-      </p:sp>
-      <p:sp>
-        <p:nvSpPr>
-          <p:cNvPr id="18" name="TextBox 17"/>
-          <p:cNvSpPr txBox="1"/>
-          <p:nvPr/>
-        </p:nvSpPr>
-        <p:spPr>
-          <a:xfrm>
-            <a:off x="1371600" y="3200400"/>
-            <a:ext cx="2926080" cy="320040"/>
-          </a:xfrm>
-          <a:prstGeom prst="rect">
-            <a:avLst/>
-          </a:prstGeom>
-          <a:noFill/>
-        </p:spPr>
-        <p:txBody>
-          <a:bodyPr wrap="square">
-            <a:spAutoFit/>
-          </a:bodyPr>
-          <a:lstStyle/>
-          <a:p>
-            <a:pPr algn="l">
-              <a:defRPr sz="1600" b="1">
-                <a:solidFill>
-                  <a:srgbClr val="FFFFFF"/>
-                </a:solidFill>
-                <a:latin typeface="Calibri"/>
-              </a:defRPr>
-            </a:pPr>
-            <a:r>
-              <a:t>FHIR Upload</a:t>
-            </a:r>
-          </a:p>
-        </p:txBody>
-      </p:sp>
-      <p:sp>
-        <p:nvSpPr>
-          <p:cNvPr id="19" name="TextBox 18"/>
-          <p:cNvSpPr txBox="1"/>
-          <p:nvPr/>
-        </p:nvSpPr>
-        <p:spPr>
-          <a:xfrm>
-            <a:off x="4389120" y="3200400"/>
-            <a:ext cx="7040880" cy="320040"/>
-          </a:xfrm>
-          <a:prstGeom prst="rect">
-            <a:avLst/>
-          </a:prstGeom>
-          <a:noFill/>
-        </p:spPr>
-        <p:txBody>
-          <a:bodyPr wrap="square">
-            <a:spAutoFit/>
-          </a:bodyPr>
-          <a:lstStyle/>
-          <a:p>
-            <a:pPr algn="l">
-              <a:defRPr sz="1400" b="0">
-                <a:solidFill>
-                  <a:srgbClr val="E8E8E8"/>
-                </a:solidFill>
-                <a:latin typeface="Calibri"/>
-              </a:defRPr>
-            </a:pPr>
-            <a:r>
-              <a:t>views.py — map LOINC/SNOMED code to new field</a:t>
-            </a:r>
-          </a:p>
-        </p:txBody>
-      </p:sp>
-      <p:sp>
-        <p:nvSpPr>
-          <p:cNvPr id="20" name="Oval 19"/>
-          <p:cNvSpPr/>
-          <p:nvPr/>
-        </p:nvSpPr>
-        <p:spPr>
-          <a:xfrm>
-            <a:off x="777240" y="3683000"/>
-            <a:ext cx="320040" cy="320040"/>
-          </a:xfrm>
-          <a:prstGeom prst="ellipse">
-            <a:avLst/>
-          </a:prstGeom>
-          <a:solidFill>
-            <a:srgbClr val="0096D6"/>
-          </a:solidFill>
-          <a:ln>
-            <a:noFill/>
-          </a:ln>
-        </p:spPr>
-        <p:style>
-          <a:lnRef idx="1">
-            <a:schemeClr val="accent1"/>
-          </a:lnRef>
-          <a:fillRef idx="3">
-            <a:schemeClr val="accent1"/>
-          </a:fillRef>
-          <a:effectRef idx="2">
-            <a:schemeClr val="accent1"/>
-          </a:effectRef>
-          <a:fontRef idx="minor">
-            <a:schemeClr val="lt1"/>
-          </a:fontRef>
-        </p:style>
-        <p:txBody>
-          <a:bodyPr rtlCol="0" anchor="ctr"/>
-          <a:lstStyle/>
-          <a:p>
-            <a:pPr algn="ctr"/>
-          </a:p>
-        </p:txBody>
-      </p:sp>
-      <p:sp>
-        <p:nvSpPr>
-          <p:cNvPr id="21" name="TextBox 20"/>
-          <p:cNvSpPr txBox="1"/>
-          <p:nvPr/>
-        </p:nvSpPr>
-        <p:spPr>
-          <a:xfrm>
-            <a:off x="731520" y="3683000"/>
-            <a:ext cx="411480" cy="320040"/>
-          </a:xfrm>
-          <a:prstGeom prst="rect">
-            <a:avLst/>
-          </a:prstGeom>
-          <a:noFill/>
-        </p:spPr>
-        <p:txBody>
-          <a:bodyPr wrap="square">
-            <a:spAutoFit/>
-          </a:bodyPr>
-          <a:lstStyle/>
-          <a:p>
-            <a:pPr algn="ctr">
-              <a:defRPr sz="1400" b="1">
-                <a:solidFill>
-                  <a:srgbClr val="FFFFFF"/>
-                </a:solidFill>
-                <a:latin typeface="Calibri"/>
-              </a:defRPr>
-            </a:pPr>
-            <a:r>
-              <a:t>5</a:t>
-            </a:r>
-          </a:p>
-        </p:txBody>
-      </p:sp>
-      <p:sp>
-        <p:nvSpPr>
-          <p:cNvPr id="22" name="TextBox 21"/>
-          <p:cNvSpPr txBox="1"/>
-          <p:nvPr/>
-        </p:nvSpPr>
-        <p:spPr>
-          <a:xfrm>
-            <a:off x="1371600" y="3657600"/>
-            <a:ext cx="2926080" cy="320040"/>
-          </a:xfrm>
-          <a:prstGeom prst="rect">
-            <a:avLst/>
-          </a:prstGeom>
-          <a:noFill/>
-        </p:spPr>
-        <p:txBody>
-          <a:bodyPr wrap="square">
-            <a:spAutoFit/>
-          </a:bodyPr>
-          <a:lstStyle/>
-          <a:p>
-            <a:pPr algn="l">
-              <a:defRPr sz="1600" b="1">
-                <a:solidFill>
-                  <a:srgbClr val="FFFFFF"/>
-                </a:solidFill>
-                <a:latin typeface="Calibri"/>
-              </a:defRPr>
-            </a:pPr>
-            <a:r>
-              <a:t>API ViewSet</a:t>
-            </a:r>
-          </a:p>
-        </p:txBody>
-      </p:sp>
-      <p:sp>
-        <p:nvSpPr>
-          <p:cNvPr id="23" name="TextBox 22"/>
-          <p:cNvSpPr txBox="1"/>
-          <p:nvPr/>
-        </p:nvSpPr>
-        <p:spPr>
-          <a:xfrm>
-            <a:off x="4389120" y="3657600"/>
-            <a:ext cx="7040880" cy="320040"/>
-          </a:xfrm>
-          <a:prstGeom prst="rect">
-            <a:avLst/>
-          </a:prstGeom>
-          <a:noFill/>
-        </p:spPr>
-        <p:txBody>
-          <a:bodyPr wrap="square">
-            <a:spAutoFit/>
-          </a:bodyPr>
-          <a:lstStyle/>
-          <a:p>
-            <a:pPr algn="l">
-              <a:defRPr sz="1400" b="0">
-                <a:solidFill>
-                  <a:srgbClr val="E8E8E8"/>
-                </a:solidFill>
-                <a:latin typeface="Calibri"/>
-              </a:defRPr>
-            </a:pPr>
-            <a:r>
-              <a:t>Add filtering/ordering if needed</a:t>
-            </a:r>
-          </a:p>
-        </p:txBody>
-      </p:sp>
-      <p:sp>
-        <p:nvSpPr>
-          <p:cNvPr id="24" name="Oval 23"/>
-          <p:cNvSpPr/>
-          <p:nvPr/>
-        </p:nvSpPr>
-        <p:spPr>
-          <a:xfrm>
-            <a:off x="777240" y="4140200"/>
-            <a:ext cx="320040" cy="320040"/>
-          </a:xfrm>
-          <a:prstGeom prst="ellipse">
-            <a:avLst/>
-          </a:prstGeom>
-          <a:solidFill>
-            <a:srgbClr val="0096D6"/>
-          </a:solidFill>
-          <a:ln>
-            <a:noFill/>
-          </a:ln>
-        </p:spPr>
-        <p:style>
-          <a:lnRef idx="1">
-            <a:schemeClr val="accent1"/>
-          </a:lnRef>
-          <a:fillRef idx="3">
-            <a:schemeClr val="accent1"/>
-          </a:fillRef>
-          <a:effectRef idx="2">
-            <a:schemeClr val="accent1"/>
-          </a:effectRef>
-          <a:fontRef idx="minor">
-            <a:schemeClr val="lt1"/>
-          </a:fontRef>
-        </p:style>
-        <p:txBody>
-          <a:bodyPr rtlCol="0" anchor="ctr"/>
-          <a:lstStyle/>
-          <a:p>
-            <a:pPr algn="ctr"/>
-          </a:p>
-        </p:txBody>
-      </p:sp>
-      <p:sp>
-        <p:nvSpPr>
-          <p:cNvPr id="25" name="TextBox 24"/>
-          <p:cNvSpPr txBox="1"/>
-          <p:nvPr/>
-        </p:nvSpPr>
-        <p:spPr>
-          <a:xfrm>
-            <a:off x="731520" y="4140200"/>
-            <a:ext cx="411480" cy="320040"/>
-          </a:xfrm>
-          <a:prstGeom prst="rect">
-            <a:avLst/>
-          </a:prstGeom>
-          <a:noFill/>
-        </p:spPr>
-        <p:txBody>
-          <a:bodyPr wrap="square">
-            <a:spAutoFit/>
-          </a:bodyPr>
-          <a:lstStyle/>
-          <a:p>
-            <a:pPr algn="ctr">
-              <a:defRPr sz="1400" b="1">
-                <a:solidFill>
-                  <a:srgbClr val="FFFFFF"/>
-                </a:solidFill>
-                <a:latin typeface="Calibri"/>
-              </a:defRPr>
-            </a:pPr>
-            <a:r>
-              <a:t>6</a:t>
-            </a:r>
-          </a:p>
-        </p:txBody>
-      </p:sp>
-      <p:sp>
-        <p:nvSpPr>
-          <p:cNvPr id="26" name="TextBox 25"/>
-          <p:cNvSpPr txBox="1"/>
-          <p:nvPr/>
-        </p:nvSpPr>
-        <p:spPr>
-          <a:xfrm>
-            <a:off x="1371600" y="4114800"/>
-            <a:ext cx="2926080" cy="320040"/>
-          </a:xfrm>
-          <a:prstGeom prst="rect">
-            <a:avLst/>
-          </a:prstGeom>
-          <a:noFill/>
-        </p:spPr>
-        <p:txBody>
-          <a:bodyPr wrap="square">
-            <a:spAutoFit/>
-          </a:bodyPr>
-          <a:lstStyle/>
-          <a:p>
-            <a:pPr algn="l">
-              <a:defRPr sz="1600" b="1">
-                <a:solidFill>
-                  <a:srgbClr val="FFFFFF"/>
-                </a:solidFill>
-                <a:latin typeface="Calibri"/>
-              </a:defRPr>
-            </a:pPr>
-            <a:r>
-              <a:t>TypeScript Type</a:t>
-            </a:r>
-          </a:p>
-        </p:txBody>
-      </p:sp>
-      <p:sp>
-        <p:nvSpPr>
-          <p:cNvPr id="27" name="TextBox 26"/>
-          <p:cNvSpPr txBox="1"/>
-          <p:nvPr/>
-        </p:nvSpPr>
-        <p:spPr>
-          <a:xfrm>
-            <a:off x="4389120" y="4114800"/>
-            <a:ext cx="7040880" cy="320040"/>
-          </a:xfrm>
-          <a:prstGeom prst="rect">
-            <a:avLst/>
-          </a:prstGeom>
-          <a:noFill/>
-        </p:spPr>
-        <p:txBody>
-          <a:bodyPr wrap="square">
-            <a:spAutoFit/>
-          </a:bodyPr>
-          <a:lstStyle/>
-          <a:p>
-            <a:pPr algn="l">
-              <a:defRPr sz="1400" b="0">
-                <a:solidFill>
-                  <a:srgbClr val="E8E8E8"/>
-                </a:solidFill>
-                <a:latin typeface="Calibri"/>
-              </a:defRPr>
-            </a:pPr>
-            <a:r>
-              <a:t>frontend/src/types/patient.ts — PatientInfo interface</a:t>
-            </a:r>
-          </a:p>
-        </p:txBody>
-      </p:sp>
-      <p:sp>
-        <p:nvSpPr>
-          <p:cNvPr id="28" name="Oval 27"/>
-          <p:cNvSpPr/>
-          <p:nvPr/>
-        </p:nvSpPr>
-        <p:spPr>
-          <a:xfrm>
-            <a:off x="777240" y="4597400"/>
-            <a:ext cx="320040" cy="320040"/>
-          </a:xfrm>
-          <a:prstGeom prst="ellipse">
-            <a:avLst/>
-          </a:prstGeom>
-          <a:solidFill>
-            <a:srgbClr val="0096D6"/>
-          </a:solidFill>
-          <a:ln>
-            <a:noFill/>
-          </a:ln>
-        </p:spPr>
-        <p:style>
-          <a:lnRef idx="1">
-            <a:schemeClr val="accent1"/>
-          </a:lnRef>
-          <a:fillRef idx="3">
-            <a:schemeClr val="accent1"/>
-          </a:fillRef>
-          <a:effectRef idx="2">
-            <a:schemeClr val="accent1"/>
-          </a:effectRef>
-          <a:fontRef idx="minor">
-            <a:schemeClr val="lt1"/>
-          </a:fontRef>
-        </p:style>
-        <p:txBody>
-          <a:bodyPr rtlCol="0" anchor="ctr"/>
-          <a:lstStyle/>
-          <a:p>
-            <a:pPr algn="ctr"/>
-          </a:p>
-        </p:txBody>
-      </p:sp>
-      <p:sp>
-        <p:nvSpPr>
-          <p:cNvPr id="29" name="TextBox 28"/>
-          <p:cNvSpPr txBox="1"/>
-          <p:nvPr/>
-        </p:nvSpPr>
-        <p:spPr>
-          <a:xfrm>
-            <a:off x="731520" y="4597400"/>
-            <a:ext cx="411480" cy="320040"/>
-          </a:xfrm>
-          <a:prstGeom prst="rect">
-            <a:avLst/>
-          </a:prstGeom>
-          <a:noFill/>
-        </p:spPr>
-        <p:txBody>
-          <a:bodyPr wrap="square">
-            <a:spAutoFit/>
-          </a:bodyPr>
-          <a:lstStyle/>
-          <a:p>
-            <a:pPr algn="ctr">
-              <a:defRPr sz="1400" b="1">
-                <a:solidFill>
-                  <a:srgbClr val="FFFFFF"/>
-                </a:solidFill>
-                <a:latin typeface="Calibri"/>
-              </a:defRPr>
-            </a:pPr>
-            <a:r>
-              <a:t>7</a:t>
-            </a:r>
-          </a:p>
-        </p:txBody>
-      </p:sp>
-      <p:sp>
-        <p:nvSpPr>
-          <p:cNvPr id="30" name="TextBox 29"/>
-          <p:cNvSpPr txBox="1"/>
-          <p:nvPr/>
-        </p:nvSpPr>
-        <p:spPr>
-          <a:xfrm>
-            <a:off x="1371600" y="4572000"/>
-            <a:ext cx="2926080" cy="320040"/>
-          </a:xfrm>
-          <a:prstGeom prst="rect">
-            <a:avLst/>
-          </a:prstGeom>
-          <a:noFill/>
-        </p:spPr>
-        <p:txBody>
-          <a:bodyPr wrap="square">
-            <a:spAutoFit/>
-          </a:bodyPr>
-          <a:lstStyle/>
-          <a:p>
-            <a:pPr algn="l">
-              <a:defRPr sz="1600" b="1">
-                <a:solidFill>
-                  <a:srgbClr val="FFFFFF"/>
-                </a:solidFill>
-                <a:latin typeface="Calibri"/>
-              </a:defRPr>
-            </a:pPr>
-            <a:r>
-              <a:t>React UI Tab</a:t>
-            </a:r>
-          </a:p>
-        </p:txBody>
-      </p:sp>
-      <p:sp>
-        <p:nvSpPr>
-          <p:cNvPr id="31" name="TextBox 30"/>
-          <p:cNvSpPr txBox="1"/>
-          <p:nvPr/>
-        </p:nvSpPr>
-        <p:spPr>
-          <a:xfrm>
-            <a:off x="4389120" y="4572000"/>
-            <a:ext cx="7040880" cy="320040"/>
-          </a:xfrm>
-          <a:prstGeom prst="rect">
-            <a:avLst/>
-          </a:prstGeom>
-          <a:noFill/>
-        </p:spPr>
-        <p:txBody>
-          <a:bodyPr wrap="square">
-            <a:spAutoFit/>
-          </a:bodyPr>
-          <a:lstStyle/>
-          <a:p>
-            <a:pPr algn="l">
-              <a:defRPr sz="1400" b="0">
-                <a:solidFill>
-                  <a:srgbClr val="E8E8E8"/>
-                </a:solidFill>
-                <a:latin typeface="Calibri"/>
-              </a:defRPr>
-            </a:pPr>
-            <a:r>
-              <a:t>GeneralTab / LabsTab / disease-specific tab</a:t>
-            </a:r>
-          </a:p>
-        </p:txBody>
-      </p:sp>
-      <p:sp>
-        <p:nvSpPr>
-          <p:cNvPr id="32" name="Oval 31"/>
-          <p:cNvSpPr/>
-          <p:nvPr/>
-        </p:nvSpPr>
-        <p:spPr>
-          <a:xfrm>
-            <a:off x="777240" y="5054600"/>
-            <a:ext cx="320040" cy="320040"/>
-          </a:xfrm>
-          <a:prstGeom prst="ellipse">
-            <a:avLst/>
-          </a:prstGeom>
-          <a:solidFill>
-            <a:srgbClr val="0096D6"/>
-          </a:solidFill>
-          <a:ln>
-            <a:noFill/>
-          </a:ln>
-        </p:spPr>
-        <p:style>
-          <a:lnRef idx="1">
-            <a:schemeClr val="accent1"/>
-          </a:lnRef>
-          <a:fillRef idx="3">
-            <a:schemeClr val="accent1"/>
-          </a:fillRef>
-          <a:effectRef idx="2">
-            <a:schemeClr val="accent1"/>
-          </a:effectRef>
-          <a:fontRef idx="minor">
-            <a:schemeClr val="lt1"/>
-          </a:fontRef>
-        </p:style>
-        <p:txBody>
-          <a:bodyPr rtlCol="0" anchor="ctr"/>
-          <a:lstStyle/>
-          <a:p>
-            <a:pPr algn="ctr"/>
-          </a:p>
-        </p:txBody>
-      </p:sp>
-      <p:sp>
-        <p:nvSpPr>
-          <p:cNvPr id="33" name="TextBox 32"/>
-          <p:cNvSpPr txBox="1"/>
-          <p:nvPr/>
-        </p:nvSpPr>
-        <p:spPr>
-          <a:xfrm>
-            <a:off x="731520" y="5054600"/>
-            <a:ext cx="411480" cy="320040"/>
-          </a:xfrm>
-          <a:prstGeom prst="rect">
-            <a:avLst/>
-          </a:prstGeom>
-          <a:noFill/>
-        </p:spPr>
-        <p:txBody>
-          <a:bodyPr wrap="square">
-            <a:spAutoFit/>
-          </a:bodyPr>
-          <a:lstStyle/>
-          <a:p>
-            <a:pPr algn="ctr">
-              <a:defRPr sz="1400" b="1">
-                <a:solidFill>
-                  <a:srgbClr val="FFFFFF"/>
-                </a:solidFill>
-                <a:latin typeface="Calibri"/>
-              </a:defRPr>
-            </a:pPr>
-            <a:r>
-              <a:t>8</a:t>
-            </a:r>
-          </a:p>
-        </p:txBody>
-      </p:sp>
-      <p:sp>
-        <p:nvSpPr>
-          <p:cNvPr id="34" name="TextBox 33"/>
-          <p:cNvSpPr txBox="1"/>
-          <p:nvPr/>
-        </p:nvSpPr>
-        <p:spPr>
-          <a:xfrm>
-            <a:off x="1371600" y="5029200"/>
-            <a:ext cx="2926080" cy="320040"/>
-          </a:xfrm>
-          <a:prstGeom prst="rect">
-            <a:avLst/>
-          </a:prstGeom>
-          <a:noFill/>
-        </p:spPr>
-        <p:txBody>
-          <a:bodyPr wrap="square">
-            <a:spAutoFit/>
-          </a:bodyPr>
-          <a:lstStyle/>
-          <a:p>
-            <a:pPr algn="l">
-              <a:defRPr sz="1600" b="1">
-                <a:solidFill>
-                  <a:srgbClr val="FFFFFF"/>
-                </a:solidFill>
-                <a:latin typeface="Calibri"/>
-              </a:defRPr>
-            </a:pPr>
-            <a:r>
-              <a:t>FHIR Generator</a:t>
-            </a:r>
-          </a:p>
-        </p:txBody>
-      </p:sp>
-      <p:sp>
-        <p:nvSpPr>
-          <p:cNvPr id="35" name="TextBox 34"/>
-          <p:cNvSpPr txBox="1"/>
-          <p:nvPr/>
-        </p:nvSpPr>
-        <p:spPr>
-          <a:xfrm>
-            <a:off x="4389120" y="5029200"/>
-            <a:ext cx="7040880" cy="320040"/>
-          </a:xfrm>
-          <a:prstGeom prst="rect">
-            <a:avLst/>
-          </a:prstGeom>
-          <a:noFill/>
-        </p:spPr>
-        <p:txBody>
-          <a:bodyPr wrap="square">
-            <a:spAutoFit/>
-          </a:bodyPr>
-          <a:lstStyle/>
-          <a:p>
-            <a:pPr algn="l">
-              <a:defRPr sz="1400" b="0">
-                <a:solidFill>
-                  <a:srgbClr val="E8E8E8"/>
-                </a:solidFill>
-                <a:latin typeface="Calibri"/>
-              </a:defRPr>
-            </a:pPr>
-            <a:r>
-              <a:t>generate_fhir_bundle.py — synthetic data for testing</a:t>
-            </a:r>
-          </a:p>
-        </p:txBody>
-      </p:sp>
-      <p:sp>
-        <p:nvSpPr>
-          <p:cNvPr id="36" name="Oval 35"/>
-          <p:cNvSpPr/>
-          <p:nvPr/>
-        </p:nvSpPr>
-        <p:spPr>
-          <a:xfrm>
-            <a:off x="777240" y="5511800"/>
-            <a:ext cx="320040" cy="320040"/>
-          </a:xfrm>
-          <a:prstGeom prst="ellipse">
-            <a:avLst/>
-          </a:prstGeom>
-          <a:solidFill>
-            <a:srgbClr val="0096D6"/>
-          </a:solidFill>
-          <a:ln>
-            <a:noFill/>
-          </a:ln>
-        </p:spPr>
-        <p:style>
-          <a:lnRef idx="1">
-            <a:schemeClr val="accent1"/>
-          </a:lnRef>
-          <a:fillRef idx="3">
-            <a:schemeClr val="accent1"/>
-          </a:fillRef>
-          <a:effectRef idx="2">
-            <a:schemeClr val="accent1"/>
-          </a:effectRef>
-          <a:fontRef idx="minor">
-            <a:schemeClr val="lt1"/>
-          </a:fontRef>
-        </p:style>
-        <p:txBody>
-          <a:bodyPr rtlCol="0" anchor="ctr"/>
-          <a:lstStyle/>
-          <a:p>
-            <a:pPr algn="ctr"/>
-          </a:p>
-        </p:txBody>
-      </p:sp>
-      <p:sp>
-        <p:nvSpPr>
-          <p:cNvPr id="37" name="TextBox 36"/>
-          <p:cNvSpPr txBox="1"/>
-          <p:nvPr/>
-        </p:nvSpPr>
-        <p:spPr>
-          <a:xfrm>
-            <a:off x="731520" y="5511800"/>
-            <a:ext cx="411480" cy="320040"/>
-          </a:xfrm>
-          <a:prstGeom prst="rect">
-            <a:avLst/>
-          </a:prstGeom>
-          <a:noFill/>
-        </p:spPr>
-        <p:txBody>
-          <a:bodyPr wrap="square">
-            <a:spAutoFit/>
-          </a:bodyPr>
-          <a:lstStyle/>
-          <a:p>
-            <a:pPr algn="ctr">
-              <a:defRPr sz="1400" b="1">
-                <a:solidFill>
-                  <a:srgbClr val="FFFFFF"/>
-                </a:solidFill>
-                <a:latin typeface="Calibri"/>
-              </a:defRPr>
-            </a:pPr>
-            <a:r>
-              <a:t>9</a:t>
-            </a:r>
-          </a:p>
-        </p:txBody>
-      </p:sp>
-      <p:sp>
-        <p:nvSpPr>
-          <p:cNvPr id="38" name="TextBox 37"/>
-          <p:cNvSpPr txBox="1"/>
-          <p:nvPr/>
-        </p:nvSpPr>
-        <p:spPr>
-          <a:xfrm>
-            <a:off x="1371600" y="5486400"/>
-            <a:ext cx="2926080" cy="320040"/>
-          </a:xfrm>
-          <a:prstGeom prst="rect">
-            <a:avLst/>
-          </a:prstGeom>
-          <a:noFill/>
-        </p:spPr>
-        <p:txBody>
-          <a:bodyPr wrap="square">
-            <a:spAutoFit/>
-          </a:bodyPr>
-          <a:lstStyle/>
-          <a:p>
-            <a:pPr algn="l">
-              <a:defRPr sz="1600" b="1">
-                <a:solidFill>
-                  <a:srgbClr val="FFFFFF"/>
-                </a:solidFill>
-                <a:latin typeface="Calibri"/>
-              </a:defRPr>
-            </a:pPr>
-            <a:r>
-              <a:t>Tests</a:t>
-            </a:r>
-          </a:p>
-        </p:txBody>
-      </p:sp>
-      <p:sp>
-        <p:nvSpPr>
-          <p:cNvPr id="39" name="TextBox 38"/>
-          <p:cNvSpPr txBox="1"/>
-          <p:nvPr/>
-        </p:nvSpPr>
-        <p:spPr>
-          <a:xfrm>
-            <a:off x="4389120" y="5486400"/>
-            <a:ext cx="7040880" cy="320040"/>
-          </a:xfrm>
-          <a:prstGeom prst="rect">
-            <a:avLst/>
-          </a:prstGeom>
-          <a:noFill/>
-        </p:spPr>
-        <p:txBody>
-          <a:bodyPr wrap="square">
-            <a:spAutoFit/>
-          </a:bodyPr>
-          <a:lstStyle/>
-          <a:p>
-            <a:pPr algn="l">
-              <a:defRPr sz="1400" b="0">
-                <a:solidFill>
-                  <a:srgbClr val="E8E8E8"/>
-                </a:solidFill>
-                <a:latin typeface="Calibri"/>
-              </a:defRPr>
-            </a:pPr>
-            <a:r>
-              <a:t>Backend model + API + FHIR upload + frontend render tests</a:t>
+            <a:pPr>
+              <a:defRPr sz="1300" b="0">
+                <a:solidFill>
+                  <a:srgbClr val="CBD5E1"/>
+                </a:solidFill>
+                <a:latin typeface="Aptos"/>
+              </a:defRPr>
+            </a:pPr>
+            <a:r>
+              <a:t>Existing mappings remain reviewable; synonyms make source fields easier to find and map consistently.</a:t>
             </a:r>
           </a:p>
         </p:txBody>

</xml_diff>

<commit_message>
docs: add PHR-S FM oncology profile guide slides
</commit_message>
<xml_diff>
--- a/PRomop_Developer_Guide.pptx
+++ b/PRomop_Developer_Guide.pptx
@@ -20,6 +20,9 @@
     <p:sldId id="269" r:id="rId20"/>
     <p:sldId id="270" r:id="rId21"/>
     <p:sldId id="271" r:id="rId22"/>
+    <p:sldId id="282" r:id="rId16"/>
+    <p:sldId id="283" r:id="rId33"/>
+    <p:sldId id="284" r:id="rId34"/>
     <p:sldId id="272" r:id="rId23"/>
     <p:sldId id="273" r:id="rId24"/>
     <p:sldId id="274" r:id="rId25"/>
@@ -3279,7 +3282,7 @@
 </p:sld>
 </file>
 
-<file path=ppt/slides/slide11.xml><?xml version="1.0" encoding="utf-8"?>
+<file path=ppt/slides/slide10.xml><?xml version="1.0" encoding="utf-8"?>
 <p:sld xmlns:a="http://schemas.openxmlformats.org/drawingml/2006/main" xmlns:p="http://schemas.openxmlformats.org/presentationml/2006/main" xmlns:r="http://schemas.openxmlformats.org/officeDocument/2006/relationships">
   <p:bg>
     <p:bgPr>
@@ -3925,7 +3928,7 @@
 </p:sld>
 </file>
 
-<file path=ppt/slides/slide12.xml><?xml version="1.0" encoding="utf-8"?>
+<file path=ppt/slides/slide11.xml><?xml version="1.0" encoding="utf-8"?>
 <p:sld xmlns:a="http://schemas.openxmlformats.org/drawingml/2006/main" xmlns:p="http://schemas.openxmlformats.org/presentationml/2006/main" xmlns:r="http://schemas.openxmlformats.org/officeDocument/2006/relationships">
   <p:bg>
     <p:bgPr>
@@ -5210,7 +5213,7 @@
 </p:sld>
 </file>
 
-<file path=ppt/slides/slide13.xml><?xml version="1.0" encoding="utf-8"?>
+<file path=ppt/slides/slide12.xml><?xml version="1.0" encoding="utf-8"?>
 <p:sld xmlns:a="http://schemas.openxmlformats.org/drawingml/2006/main" xmlns:p="http://schemas.openxmlformats.org/presentationml/2006/main" xmlns:r="http://schemas.openxmlformats.org/officeDocument/2006/relationships">
   <p:bg>
     <p:bgPr>
@@ -6102,7 +6105,7 @@
 </p:sld>
 </file>
 
-<file path=ppt/slides/slide14.xml><?xml version="1.0" encoding="utf-8"?>
+<file path=ppt/slides/slide13.xml><?xml version="1.0" encoding="utf-8"?>
 <p:sld xmlns:a="http://schemas.openxmlformats.org/drawingml/2006/main" xmlns:p="http://schemas.openxmlformats.org/presentationml/2006/main" xmlns:r="http://schemas.openxmlformats.org/officeDocument/2006/relationships">
   <p:bg>
     <p:bgPr>
@@ -6948,7 +6951,7 @@
 </p:sld>
 </file>
 
-<file path=ppt/slides/slide15.xml><?xml version="1.0" encoding="utf-8"?>
+<file path=ppt/slides/slide14.xml><?xml version="1.0" encoding="utf-8"?>
 <p:sld xmlns:a="http://schemas.openxmlformats.org/drawingml/2006/main" xmlns:p="http://schemas.openxmlformats.org/presentationml/2006/main" xmlns:r="http://schemas.openxmlformats.org/officeDocument/2006/relationships">
   <p:bg>
     <p:bgPr>
@@ -7442,7 +7445,7 @@
 </p:sld>
 </file>
 
-<file path=ppt/slides/slide16.xml><?xml version="1.0" encoding="utf-8"?>
+<file path=ppt/slides/slide15.xml><?xml version="1.0" encoding="utf-8"?>
 <p:sld xmlns:a="http://schemas.openxmlformats.org/drawingml/2006/main" xmlns:p="http://schemas.openxmlformats.org/presentationml/2006/main" xmlns:r="http://schemas.openxmlformats.org/officeDocument/2006/relationships">
   <p:bg>
     <p:bgPr>
@@ -8366,7 +8369,7 @@
 </p:sld>
 </file>
 
-<file path=ppt/slides/slide17.xml><?xml version="1.0" encoding="utf-8"?>
+<file path=ppt/slides/slide16.xml><?xml version="1.0" encoding="utf-8"?>
 <p:sld xmlns:a="http://schemas.openxmlformats.org/drawingml/2006/main" xmlns:p="http://schemas.openxmlformats.org/presentationml/2006/main" xmlns:r="http://schemas.openxmlformats.org/officeDocument/2006/relationships">
   <p:bg>
     <p:bgPr>
@@ -8456,7 +8459,7 @@
 </p:sld>
 </file>
 
-<file path=ppt/slides/slide18.xml><?xml version="1.0" encoding="utf-8"?>
+<file path=ppt/slides/slide17.xml><?xml version="1.0" encoding="utf-8"?>
 <p:sld xmlns:a="http://schemas.openxmlformats.org/drawingml/2006/main" xmlns:p="http://schemas.openxmlformats.org/presentationml/2006/main" xmlns:r="http://schemas.openxmlformats.org/officeDocument/2006/relationships">
   <p:bg>
     <p:bgPr>
@@ -8633,7 +8636,7 @@
 </p:sld>
 </file>
 
-<file path=ppt/slides/slide19.xml><?xml version="1.0" encoding="utf-8"?>
+<file path=ppt/slides/slide18.xml><?xml version="1.0" encoding="utf-8"?>
 <p:sld xmlns:a="http://schemas.openxmlformats.org/drawingml/2006/main" xmlns:p="http://schemas.openxmlformats.org/presentationml/2006/main" xmlns:r="http://schemas.openxmlformats.org/officeDocument/2006/relationships">
   <p:bg>
     <p:bgPr>
@@ -9705,331 +9708,7 @@
 </p:sld>
 </file>
 
-<file path=ppt/slides/slide2.xml><?xml version="1.0" encoding="utf-8"?>
-<p:sld xmlns:a="http://schemas.openxmlformats.org/drawingml/2006/main" xmlns:p="http://schemas.openxmlformats.org/presentationml/2006/main" xmlns:r="http://schemas.openxmlformats.org/officeDocument/2006/relationships">
-  <p:bg>
-    <p:bgPr>
-      <a:solidFill>
-        <a:srgbClr val="1A1A2E"/>
-      </a:solidFill>
-      <a:effectLst/>
-    </p:bgPr>
-  </p:bg>
-  <p:cSld>
-    <p:spTree>
-      <p:nvGrpSpPr>
-        <p:cNvPr id="1" name=""/>
-        <p:cNvGrpSpPr/>
-        <p:nvPr/>
-      </p:nvGrpSpPr>
-      <p:grpSpPr/>
-      <p:sp>
-        <p:nvSpPr>
-          <p:cNvPr id="2" name="TB2"/>
-          <p:cNvSpPr txBox="1"/>
-          <p:nvPr/>
-        </p:nvSpPr>
-        <p:spPr>
-          <a:xfrm>
-            <a:off x="731520" y="365760"/>
-            <a:ext cx="10058400" cy="640080"/>
-          </a:xfrm>
-          <a:prstGeom prst="rect">
-            <a:avLst/>
-          </a:prstGeom>
-          <a:noFill/>
-        </p:spPr>
-        <p:txBody>
-          <a:bodyPr wrap="square">
-            <a:spAutoFit/>
-          </a:bodyPr>
-          <a:lstStyle/>
-          <a:p>
-            <a:pPr>
-              <a:defRPr sz="3200" b="1">
-                <a:solidFill>
-                  <a:srgbClr val="0096D6"/>
-                </a:solidFill>
-                <a:latin typeface="Calibri"/>
-              </a:defRPr>
-            </a:pPr>
-            <a:r>
-              <a:rPr lang="en-US" sz="3200">
-                <a:solidFill>
-                  <a:srgbClr val="0096D6"/>
-                </a:solidFill>
-                <a:latin typeface="Calibri"/>
-              </a:rPr>
-              <a:t>Why Build PRomop?</a:t>
-            </a:r>
-          </a:p>
-        </p:txBody>
-      </p:sp>
-      <p:sp>
-        <p:nvSpPr>
-          <p:cNvPr id="3" name="TB3"/>
-          <p:cNvSpPr txBox="1"/>
-          <p:nvPr/>
-        </p:nvSpPr>
-        <p:spPr>
-          <a:xfrm>
-            <a:off x="731520" y="1280160"/>
-            <a:ext cx="10058400" cy="5029200"/>
-          </a:xfrm>
-          <a:prstGeom prst="rect">
-            <a:avLst/>
-          </a:prstGeom>
-          <a:noFill/>
-        </p:spPr>
-        <p:txBody>
-          <a:bodyPr wrap="square">
-            <a:spAutoFit/>
-          </a:bodyPr>
-          <a:lstStyle/>
-          <a:p>
-            <a:pPr>
-              <a:spcAft>
-                <a:spcPts val="400"/>
-              </a:spcAft>
-              <a:defRPr sz="2000" b="1">
-                <a:solidFill>
-                  <a:srgbClr val="0096D6"/>
-                </a:solidFill>
-                <a:latin typeface="Calibri"/>
-              </a:defRPr>
-            </a:pPr>
-            <a:r>
-              <a:rPr lang="en-US" sz="2000">
-                <a:solidFill>
-                  <a:srgbClr val="0096D6"/>
-                </a:solidFill>
-                <a:latin typeface="Calibri"/>
-              </a:rPr>
-              <a:t>The Gap in Health Data Infrastructure</a:t>
-            </a:r>
-          </a:p>
-          <a:p>
-            <a:pPr>
-              <a:spcAft>
-                <a:spcPts val="200"/>
-              </a:spcAft>
-              <a:defRPr sz="1600">
-                <a:solidFill>
-                  <a:srgbClr val="E8E8E8"/>
-                </a:solidFill>
-                <a:latin typeface="Calibri"/>
-              </a:defRPr>
-            </a:pPr>
-            <a:r>
-              <a:rPr lang="en-US" sz="1600">
-                <a:solidFill>
-                  <a:srgbClr val="E8E8E8"/>
-                </a:solidFill>
-                <a:latin typeface="Calibri"/>
-              </a:rPr>
-              <a:t>Three approaches exist today — none serve the individual patient:</a:t>
-            </a:r>
-          </a:p>
-          <a:p>
-            <a:pPr>
-              <a:spcBef>
-                <a:spcPts val="400"/>
-              </a:spcBef>
-              <a:spcAft>
-                <a:spcPts val="200"/>
-              </a:spcAft>
-              <a:defRPr sz="1500">
-                <a:solidFill>
-                  <a:srgbClr val="E8E8E8"/>
-                </a:solidFill>
-                <a:latin typeface="Calibri"/>
-              </a:defRPr>
-            </a:pPr>
-            <a:r>
-              <a:rPr lang="en-US" sz="1500" b="1">
-                <a:solidFill>
-                  <a:srgbClr val="0096D6"/>
-                </a:solidFill>
-                <a:latin typeface="Calibri"/>
-              </a:rPr>
-              <a:t>•  OHDSI research data lakes  —  </a:t>
-            </a:r>
-            <a:r>
-              <a:rPr lang="en-US" sz="1500">
-                <a:solidFill>
-                  <a:srgbClr val="E8E8E8"/>
-                </a:solidFill>
-                <a:latin typeface="Calibri"/>
-              </a:rPr>
-              <a:t>optimized for population studies across institutions; deliberately exclude columns needed for individual clinical service</a:t>
-            </a:r>
-          </a:p>
-          <a:p>
-            <a:pPr>
-              <a:spcBef>
-                <a:spcPts val="400"/>
-              </a:spcBef>
-              <a:spcAft>
-                <a:spcPts val="200"/>
-              </a:spcAft>
-              <a:defRPr sz="1500">
-                <a:solidFill>
-                  <a:srgbClr val="E8E8E8"/>
-                </a:solidFill>
-                <a:latin typeface="Calibri"/>
-              </a:defRPr>
-            </a:pPr>
-            <a:r>
-              <a:rPr lang="en-US" sz="1500" b="1">
-                <a:solidFill>
-                  <a:srgbClr val="0096D6"/>
-                </a:solidFill>
-                <a:latin typeface="Calibri"/>
-              </a:rPr>
-              <a:t>•  EHR-tethered PHR add-ons  —  </a:t>
-            </a:r>
-            <a:r>
-              <a:rPr lang="en-US" sz="1500">
-                <a:solidFill>
-                  <a:srgbClr val="E8E8E8"/>
-                </a:solidFill>
-                <a:latin typeface="Calibri"/>
-              </a:rPr>
-              <a:t>provider-controlled portals; patients can view but don't own or control their data</a:t>
-            </a:r>
-          </a:p>
-          <a:p>
-            <a:pPr>
-              <a:spcBef>
-                <a:spcPts val="400"/>
-              </a:spcBef>
-              <a:spcAft>
-                <a:spcPts val="200"/>
-              </a:spcAft>
-              <a:defRPr sz="1500">
-                <a:solidFill>
-                  <a:srgbClr val="E8E8E8"/>
-                </a:solidFill>
-                <a:latin typeface="Calibri"/>
-              </a:defRPr>
-            </a:pPr>
-            <a:r>
-              <a:rPr lang="en-US" sz="1500" b="1">
-                <a:solidFill>
-                  <a:srgbClr val="0096D6"/>
-                </a:solidFill>
-                <a:latin typeface="Calibri"/>
-              </a:rPr>
-              <a:t>•  Closed commercial platforms  —  </a:t>
-            </a:r>
-            <a:r>
-              <a:rPr lang="en-US" sz="1500">
-                <a:solidFill>
-                  <a:srgbClr val="E8E8E8"/>
-                </a:solidFill>
-                <a:latin typeface="Calibri"/>
-              </a:rPr>
-              <a:t>proprietary, limited interoperability, no guaranteed data portability</a:t>
-            </a:r>
-          </a:p>
-          <a:p>
-            <a:pPr>
-              <a:spcBef>
-                <a:spcPts val="800"/>
-              </a:spcBef>
-              <a:spcAft>
-                <a:spcPts val="200"/>
-              </a:spcAft>
-              <a:defRPr sz="1800" b="1">
-                <a:solidFill>
-                  <a:srgbClr val="0096D6"/>
-                </a:solidFill>
-                <a:latin typeface="Calibri"/>
-              </a:defRPr>
-            </a:pPr>
-            <a:r>
-              <a:rPr lang="en-US" sz="1800">
-                <a:solidFill>
-                  <a:srgbClr val="0096D6"/>
-                </a:solidFill>
-                <a:latin typeface="Calibri"/>
-              </a:rPr>
-              <a:t>What's missing:</a:t>
-            </a:r>
-          </a:p>
-          <a:p>
-            <a:pPr>
-              <a:spcBef>
-                <a:spcPts val="200"/>
-              </a:spcBef>
-              <a:defRPr sz="1600">
-                <a:solidFill>
-                  <a:srgbClr val="E8E8E8"/>
-                </a:solidFill>
-                <a:latin typeface="Calibri"/>
-              </a:defRPr>
-            </a:pPr>
-            <a:r>
-              <a:rPr lang="en-US" sz="1600">
-                <a:solidFill>
-                  <a:srgbClr val="E8E8E8"/>
-                </a:solidFill>
-                <a:latin typeface="Calibri"/>
-              </a:rPr>
-              <a:t>A </a:t>
-            </a:r>
-            <a:r>
-              <a:rPr lang="en-US" sz="1600" b="1">
-                <a:solidFill>
-                  <a:srgbClr val="4EC9B0"/>
-                </a:solidFill>
-                <a:latin typeface="Calibri"/>
-              </a:rPr>
-              <a:t>patient-custodied</a:t>
-            </a:r>
-            <a:r>
-              <a:rPr lang="en-US" sz="1600">
-                <a:solidFill>
-                  <a:srgbClr val="E8E8E8"/>
-                </a:solidFill>
-                <a:latin typeface="Calibri"/>
-              </a:rPr>
-              <a:t> longitudinal health record that integrates clinical data, wearables, and patient-reported outcomes — built on open standards, with guaranteed portability.</a:t>
-            </a:r>
-          </a:p>
-          <a:p>
-            <a:pPr>
-              <a:spcBef>
-                <a:spcPts val="600"/>
-              </a:spcBef>
-              <a:defRPr sz="1400" i="1">
-                <a:solidFill>
-                  <a:srgbClr val="999999"/>
-                </a:solidFill>
-                <a:latin typeface="Calibri"/>
-              </a:defRPr>
-            </a:pPr>
-            <a:r>
-              <a:rPr lang="en-US" sz="1400" i="1">
-                <a:solidFill>
-                  <a:srgbClr val="999999"/>
-                </a:solidFill>
-                <a:latin typeface="Calibri"/>
-              </a:rPr>
-              <a:t>Validated with 14,000+ oncology patients and a decade of longitudinal follow-up at HealthTree Foundation.</a:t>
-            </a:r>
-          </a:p>
-        </p:txBody>
-      </p:sp>
-    </p:spTree>
-  </p:cSld>
-  <p:clrMapOvr>
-    <a:masterClrMapping/>
-  </p:clrMapOvr>
-</p:sld>
-</file>
-
-<file path=ppt/slides/slide20.xml><?xml version="1.0" encoding="utf-8"?>
+<file path=ppt/slides/slide19.xml><?xml version="1.0" encoding="utf-8"?>
 <p:sld xmlns:a="http://schemas.openxmlformats.org/drawingml/2006/main" xmlns:p="http://schemas.openxmlformats.org/presentationml/2006/main" xmlns:r="http://schemas.openxmlformats.org/officeDocument/2006/relationships">
   <p:bg>
     <p:bgPr>
@@ -11416,7 +11095,331 @@
 </p:sld>
 </file>
 
-<file path=ppt/slides/slide21.xml><?xml version="1.0" encoding="utf-8"?>
+<file path=ppt/slides/slide2.xml><?xml version="1.0" encoding="utf-8"?>
+<p:sld xmlns:a="http://schemas.openxmlformats.org/drawingml/2006/main" xmlns:p="http://schemas.openxmlformats.org/presentationml/2006/main" xmlns:r="http://schemas.openxmlformats.org/officeDocument/2006/relationships">
+  <p:bg>
+    <p:bgPr>
+      <a:solidFill>
+        <a:srgbClr val="1A1A2E"/>
+      </a:solidFill>
+      <a:effectLst/>
+    </p:bgPr>
+  </p:bg>
+  <p:cSld>
+    <p:spTree>
+      <p:nvGrpSpPr>
+        <p:cNvPr id="1" name=""/>
+        <p:cNvGrpSpPr/>
+        <p:nvPr/>
+      </p:nvGrpSpPr>
+      <p:grpSpPr/>
+      <p:sp>
+        <p:nvSpPr>
+          <p:cNvPr id="2" name="TB2"/>
+          <p:cNvSpPr txBox="1"/>
+          <p:nvPr/>
+        </p:nvSpPr>
+        <p:spPr>
+          <a:xfrm>
+            <a:off x="731520" y="365760"/>
+            <a:ext cx="10058400" cy="640080"/>
+          </a:xfrm>
+          <a:prstGeom prst="rect">
+            <a:avLst/>
+          </a:prstGeom>
+          <a:noFill/>
+        </p:spPr>
+        <p:txBody>
+          <a:bodyPr wrap="square">
+            <a:spAutoFit/>
+          </a:bodyPr>
+          <a:lstStyle/>
+          <a:p>
+            <a:pPr>
+              <a:defRPr sz="3200" b="1">
+                <a:solidFill>
+                  <a:srgbClr val="0096D6"/>
+                </a:solidFill>
+                <a:latin typeface="Calibri"/>
+              </a:defRPr>
+            </a:pPr>
+            <a:r>
+              <a:rPr lang="en-US" sz="3200">
+                <a:solidFill>
+                  <a:srgbClr val="0096D6"/>
+                </a:solidFill>
+                <a:latin typeface="Calibri"/>
+              </a:rPr>
+              <a:t>Why Build PRomop?</a:t>
+            </a:r>
+          </a:p>
+        </p:txBody>
+      </p:sp>
+      <p:sp>
+        <p:nvSpPr>
+          <p:cNvPr id="3" name="TB3"/>
+          <p:cNvSpPr txBox="1"/>
+          <p:nvPr/>
+        </p:nvSpPr>
+        <p:spPr>
+          <a:xfrm>
+            <a:off x="731520" y="1280160"/>
+            <a:ext cx="10058400" cy="5029200"/>
+          </a:xfrm>
+          <a:prstGeom prst="rect">
+            <a:avLst/>
+          </a:prstGeom>
+          <a:noFill/>
+        </p:spPr>
+        <p:txBody>
+          <a:bodyPr wrap="square">
+            <a:spAutoFit/>
+          </a:bodyPr>
+          <a:lstStyle/>
+          <a:p>
+            <a:pPr>
+              <a:spcAft>
+                <a:spcPts val="400"/>
+              </a:spcAft>
+              <a:defRPr sz="2000" b="1">
+                <a:solidFill>
+                  <a:srgbClr val="0096D6"/>
+                </a:solidFill>
+                <a:latin typeface="Calibri"/>
+              </a:defRPr>
+            </a:pPr>
+            <a:r>
+              <a:rPr lang="en-US" sz="2000">
+                <a:solidFill>
+                  <a:srgbClr val="0096D6"/>
+                </a:solidFill>
+                <a:latin typeface="Calibri"/>
+              </a:rPr>
+              <a:t>The Gap in Health Data Infrastructure</a:t>
+            </a:r>
+          </a:p>
+          <a:p>
+            <a:pPr>
+              <a:spcAft>
+                <a:spcPts val="200"/>
+              </a:spcAft>
+              <a:defRPr sz="1600">
+                <a:solidFill>
+                  <a:srgbClr val="E8E8E8"/>
+                </a:solidFill>
+                <a:latin typeface="Calibri"/>
+              </a:defRPr>
+            </a:pPr>
+            <a:r>
+              <a:rPr lang="en-US" sz="1600">
+                <a:solidFill>
+                  <a:srgbClr val="E8E8E8"/>
+                </a:solidFill>
+                <a:latin typeface="Calibri"/>
+              </a:rPr>
+              <a:t>Three approaches exist today — none serve the individual patient:</a:t>
+            </a:r>
+          </a:p>
+          <a:p>
+            <a:pPr>
+              <a:spcBef>
+                <a:spcPts val="400"/>
+              </a:spcBef>
+              <a:spcAft>
+                <a:spcPts val="200"/>
+              </a:spcAft>
+              <a:defRPr sz="1500">
+                <a:solidFill>
+                  <a:srgbClr val="E8E8E8"/>
+                </a:solidFill>
+                <a:latin typeface="Calibri"/>
+              </a:defRPr>
+            </a:pPr>
+            <a:r>
+              <a:rPr lang="en-US" sz="1500" b="1">
+                <a:solidFill>
+                  <a:srgbClr val="0096D6"/>
+                </a:solidFill>
+                <a:latin typeface="Calibri"/>
+              </a:rPr>
+              <a:t>•  OHDSI research data lakes  —  </a:t>
+            </a:r>
+            <a:r>
+              <a:rPr lang="en-US" sz="1500">
+                <a:solidFill>
+                  <a:srgbClr val="E8E8E8"/>
+                </a:solidFill>
+                <a:latin typeface="Calibri"/>
+              </a:rPr>
+              <a:t>optimized for population studies across institutions; deliberately exclude columns needed for individual clinical service</a:t>
+            </a:r>
+          </a:p>
+          <a:p>
+            <a:pPr>
+              <a:spcBef>
+                <a:spcPts val="400"/>
+              </a:spcBef>
+              <a:spcAft>
+                <a:spcPts val="200"/>
+              </a:spcAft>
+              <a:defRPr sz="1500">
+                <a:solidFill>
+                  <a:srgbClr val="E8E8E8"/>
+                </a:solidFill>
+                <a:latin typeface="Calibri"/>
+              </a:defRPr>
+            </a:pPr>
+            <a:r>
+              <a:rPr lang="en-US" sz="1500" b="1">
+                <a:solidFill>
+                  <a:srgbClr val="0096D6"/>
+                </a:solidFill>
+                <a:latin typeface="Calibri"/>
+              </a:rPr>
+              <a:t>•  EHR-tethered PHR add-ons  —  </a:t>
+            </a:r>
+            <a:r>
+              <a:rPr lang="en-US" sz="1500">
+                <a:solidFill>
+                  <a:srgbClr val="E8E8E8"/>
+                </a:solidFill>
+                <a:latin typeface="Calibri"/>
+              </a:rPr>
+              <a:t>provider-controlled portals; patients can view but don't own or control their data</a:t>
+            </a:r>
+          </a:p>
+          <a:p>
+            <a:pPr>
+              <a:spcBef>
+                <a:spcPts val="400"/>
+              </a:spcBef>
+              <a:spcAft>
+                <a:spcPts val="200"/>
+              </a:spcAft>
+              <a:defRPr sz="1500">
+                <a:solidFill>
+                  <a:srgbClr val="E8E8E8"/>
+                </a:solidFill>
+                <a:latin typeface="Calibri"/>
+              </a:defRPr>
+            </a:pPr>
+            <a:r>
+              <a:rPr lang="en-US" sz="1500" b="1">
+                <a:solidFill>
+                  <a:srgbClr val="0096D6"/>
+                </a:solidFill>
+                <a:latin typeface="Calibri"/>
+              </a:rPr>
+              <a:t>•  Closed commercial platforms  —  </a:t>
+            </a:r>
+            <a:r>
+              <a:rPr lang="en-US" sz="1500">
+                <a:solidFill>
+                  <a:srgbClr val="E8E8E8"/>
+                </a:solidFill>
+                <a:latin typeface="Calibri"/>
+              </a:rPr>
+              <a:t>proprietary, limited interoperability, no guaranteed data portability</a:t>
+            </a:r>
+          </a:p>
+          <a:p>
+            <a:pPr>
+              <a:spcBef>
+                <a:spcPts val="800"/>
+              </a:spcBef>
+              <a:spcAft>
+                <a:spcPts val="200"/>
+              </a:spcAft>
+              <a:defRPr sz="1800" b="1">
+                <a:solidFill>
+                  <a:srgbClr val="0096D6"/>
+                </a:solidFill>
+                <a:latin typeface="Calibri"/>
+              </a:defRPr>
+            </a:pPr>
+            <a:r>
+              <a:rPr lang="en-US" sz="1800">
+                <a:solidFill>
+                  <a:srgbClr val="0096D6"/>
+                </a:solidFill>
+                <a:latin typeface="Calibri"/>
+              </a:rPr>
+              <a:t>What's missing:</a:t>
+            </a:r>
+          </a:p>
+          <a:p>
+            <a:pPr>
+              <a:spcBef>
+                <a:spcPts val="200"/>
+              </a:spcBef>
+              <a:defRPr sz="1600">
+                <a:solidFill>
+                  <a:srgbClr val="E8E8E8"/>
+                </a:solidFill>
+                <a:latin typeface="Calibri"/>
+              </a:defRPr>
+            </a:pPr>
+            <a:r>
+              <a:rPr lang="en-US" sz="1600">
+                <a:solidFill>
+                  <a:srgbClr val="E8E8E8"/>
+                </a:solidFill>
+                <a:latin typeface="Calibri"/>
+              </a:rPr>
+              <a:t>A </a:t>
+            </a:r>
+            <a:r>
+              <a:rPr lang="en-US" sz="1600" b="1">
+                <a:solidFill>
+                  <a:srgbClr val="4EC9B0"/>
+                </a:solidFill>
+                <a:latin typeface="Calibri"/>
+              </a:rPr>
+              <a:t>patient-custodied</a:t>
+            </a:r>
+            <a:r>
+              <a:rPr lang="en-US" sz="1600">
+                <a:solidFill>
+                  <a:srgbClr val="E8E8E8"/>
+                </a:solidFill>
+                <a:latin typeface="Calibri"/>
+              </a:rPr>
+              <a:t> longitudinal health record that integrates clinical data, wearables, and patient-reported outcomes — built on open standards, with guaranteed portability.</a:t>
+            </a:r>
+          </a:p>
+          <a:p>
+            <a:pPr>
+              <a:spcBef>
+                <a:spcPts val="600"/>
+              </a:spcBef>
+              <a:defRPr sz="1400" i="1">
+                <a:solidFill>
+                  <a:srgbClr val="999999"/>
+                </a:solidFill>
+                <a:latin typeface="Calibri"/>
+              </a:defRPr>
+            </a:pPr>
+            <a:r>
+              <a:rPr lang="en-US" sz="1400" i="1">
+                <a:solidFill>
+                  <a:srgbClr val="999999"/>
+                </a:solidFill>
+                <a:latin typeface="Calibri"/>
+              </a:rPr>
+              <a:t>Validated with 14,000+ oncology patients and a decade of longitudinal follow-up at HealthTree Foundation.</a:t>
+            </a:r>
+          </a:p>
+        </p:txBody>
+      </p:sp>
+    </p:spTree>
+  </p:cSld>
+  <p:clrMapOvr>
+    <a:masterClrMapping/>
+  </p:clrMapOvr>
+</p:sld>
+</file>
+
+<file path=ppt/slides/slide20.xml><?xml version="1.0" encoding="utf-8"?>
 <p:sld xmlns:a="http://schemas.openxmlformats.org/drawingml/2006/main" xmlns:p="http://schemas.openxmlformats.org/presentationml/2006/main" xmlns:r="http://schemas.openxmlformats.org/officeDocument/2006/relationships">
   <p:bg>
     <p:bgPr>
@@ -12496,7 +12499,7 @@
 </p:sld>
 </file>
 
-<file path=ppt/slides/slide22.xml><?xml version="1.0" encoding="utf-8"?>
+<file path=ppt/slides/slide21.xml><?xml version="1.0" encoding="utf-8"?>
 <p:sld xmlns:a="http://schemas.openxmlformats.org/drawingml/2006/main" xmlns:p="http://schemas.openxmlformats.org/presentationml/2006/main" xmlns:r="http://schemas.openxmlformats.org/officeDocument/2006/relationships">
   <p:bg>
     <p:bgPr>
@@ -13564,7 +13567,7 @@
 </p:sld>
 </file>
 
-<file path=ppt/slides/slide23.xml><?xml version="1.0" encoding="utf-8"?>
+<file path=ppt/slides/slide22.xml><?xml version="1.0" encoding="utf-8"?>
 <p:sld xmlns:a="http://schemas.openxmlformats.org/drawingml/2006/main" xmlns:p="http://schemas.openxmlformats.org/presentationml/2006/main" xmlns:r="http://schemas.openxmlformats.org/officeDocument/2006/relationships">
   <p:bg>
     <p:bgPr>
@@ -14456,7 +14459,7 @@
 </p:sld>
 </file>
 
-<file path=ppt/slides/slide24.xml><?xml version="1.0" encoding="utf-8"?>
+<file path=ppt/slides/slide23.xml><?xml version="1.0" encoding="utf-8"?>
 <p:sld xmlns:a="http://schemas.openxmlformats.org/drawingml/2006/main" xmlns:p="http://schemas.openxmlformats.org/presentationml/2006/main" xmlns:r="http://schemas.openxmlformats.org/officeDocument/2006/relationships">
   <p:bg>
     <p:bgPr>
@@ -15627,7 +15630,7 @@
 </p:sld>
 </file>
 
-<file path=ppt/slides/slide25.xml><?xml version="1.0" encoding="utf-8"?>
+<file path=ppt/slides/slide24.xml><?xml version="1.0" encoding="utf-8"?>
 <p:sld xmlns:a="http://schemas.openxmlformats.org/drawingml/2006/main" xmlns:p="http://schemas.openxmlformats.org/presentationml/2006/main" xmlns:r="http://schemas.openxmlformats.org/officeDocument/2006/relationships">
   <p:bg>
     <p:bgPr>
@@ -16933,7 +16936,7 @@
 </p:sld>
 </file>
 
-<file path=ppt/slides/slide26.xml><?xml version="1.0" encoding="utf-8"?>
+<file path=ppt/slides/slide25.xml><?xml version="1.0" encoding="utf-8"?>
 <p:sld xmlns:a="http://schemas.openxmlformats.org/drawingml/2006/main" xmlns:p="http://schemas.openxmlformats.org/presentationml/2006/main" xmlns:r="http://schemas.openxmlformats.org/officeDocument/2006/relationships">
   <p:bg>
     <p:bgPr>
@@ -17854,6 +17857,1647 @@
             </a:pPr>
             <a:r>
               <a:t># All standard OMOP query patterns apply.</a:t>
+            </a:r>
+          </a:p>
+        </p:txBody>
+      </p:sp>
+    </p:spTree>
+  </p:cSld>
+  <p:clrMapOvr>
+    <a:masterClrMapping/>
+  </p:clrMapOvr>
+</p:sld>
+</file>
+
+<file path=ppt/slides/slide26.xml><?xml version="1.0" encoding="utf-8"?>
+<p:sld xmlns:a="http://schemas.openxmlformats.org/drawingml/2006/main" xmlns:p="http://schemas.openxmlformats.org/presentationml/2006/main" xmlns:r="http://schemas.openxmlformats.org/officeDocument/2006/relationships">
+  <p:cSld>
+    <p:bg>
+      <p:bgPr>
+        <a:solidFill>
+          <a:srgbClr val="0F172A"/>
+        </a:solidFill>
+        <a:effectLst/>
+      </p:bgPr>
+    </p:bg>
+    <p:spTree>
+      <p:nvGrpSpPr>
+        <p:cNvPr id="1" name=""/>
+        <p:cNvGrpSpPr/>
+        <p:nvPr/>
+      </p:nvGrpSpPr>
+      <p:grpSpPr/>
+      <p:sp>
+        <p:nvSpPr>
+          <p:cNvPr id="2" name="TextBox 1"/>
+          <p:cNvSpPr txBox="1"/>
+          <p:nvPr/>
+        </p:nvSpPr>
+        <p:spPr>
+          <a:xfrm>
+            <a:off x="731520" y="365760"/>
+            <a:ext cx="10698480" cy="502920"/>
+          </a:xfrm>
+          <a:prstGeom prst="rect">
+            <a:avLst/>
+          </a:prstGeom>
+          <a:noFill/>
+        </p:spPr>
+        <p:txBody>
+          <a:bodyPr wrap="square" anchor="t">
+            <a:spAutoFit/>
+          </a:bodyPr>
+          <a:lstStyle/>
+          <a:p>
+            <a:pPr algn="l">
+              <a:defRPr sz="3200" b="1">
+                <a:solidFill>
+                  <a:srgbClr val="0096D6"/>
+                </a:solidFill>
+                <a:latin typeface="Calibri"/>
+              </a:defRPr>
+            </a:pPr>
+            <a:r>
+              <a:t>HL7 PHR-S FM R2 — Oncology Profile</a:t>
+            </a:r>
+          </a:p>
+        </p:txBody>
+      </p:sp>
+      <p:sp>
+        <p:nvSpPr>
+          <p:cNvPr id="3" name="TextBox 2"/>
+          <p:cNvSpPr txBox="1"/>
+          <p:nvPr/>
+        </p:nvSpPr>
+        <p:spPr>
+          <a:xfrm>
+            <a:off x="731520" y="1024128"/>
+            <a:ext cx="10607040" cy="365760"/>
+          </a:xfrm>
+          <a:prstGeom prst="rect">
+            <a:avLst/>
+          </a:prstGeom>
+          <a:noFill/>
+        </p:spPr>
+        <p:txBody>
+          <a:bodyPr wrap="square" anchor="t">
+            <a:spAutoFit/>
+          </a:bodyPr>
+          <a:lstStyle/>
+          <a:p>
+            <a:pPr algn="l">
+              <a:defRPr sz="1700" b="0">
+                <a:solidFill>
+                  <a:srgbClr val="E8E8E8"/>
+                </a:solidFill>
+                <a:latin typeface="Calibri"/>
+              </a:defRPr>
+            </a:pPr>
+            <a:r>
+              <a:t>A scoped functional profile for PRomop / HealthKey.ai's oncology patient PHR.</a:t>
+            </a:r>
+          </a:p>
+        </p:txBody>
+      </p:sp>
+      <p:sp>
+        <p:nvSpPr>
+          <p:cNvPr id="4" name="TextBox 3"/>
+          <p:cNvSpPr txBox="1"/>
+          <p:nvPr/>
+        </p:nvSpPr>
+        <p:spPr>
+          <a:xfrm>
+            <a:off x="731520" y="1627632"/>
+            <a:ext cx="3108960" cy="320040"/>
+          </a:xfrm>
+          <a:prstGeom prst="rect">
+            <a:avLst/>
+          </a:prstGeom>
+          <a:noFill/>
+        </p:spPr>
+        <p:txBody>
+          <a:bodyPr wrap="square" anchor="t">
+            <a:spAutoFit/>
+          </a:bodyPr>
+          <a:lstStyle/>
+          <a:p>
+            <a:pPr algn="l">
+              <a:defRPr sz="1800" b="1">
+                <a:solidFill>
+                  <a:srgbClr val="2ECC71"/>
+                </a:solidFill>
+                <a:latin typeface="Calibri"/>
+              </a:defRPr>
+            </a:pPr>
+            <a:r>
+              <a:t>What we claim</a:t>
+            </a:r>
+          </a:p>
+        </p:txBody>
+      </p:sp>
+      <p:sp>
+        <p:nvSpPr>
+          <p:cNvPr id="5" name="TextBox 4"/>
+          <p:cNvSpPr txBox="1"/>
+          <p:nvPr/>
+        </p:nvSpPr>
+        <p:spPr>
+          <a:xfrm>
+            <a:off x="731520" y="1984248"/>
+            <a:ext cx="5303520" cy="914400"/>
+          </a:xfrm>
+          <a:prstGeom prst="rect">
+            <a:avLst/>
+          </a:prstGeom>
+          <a:noFill/>
+        </p:spPr>
+        <p:txBody>
+          <a:bodyPr wrap="square" anchor="t">
+            <a:spAutoFit/>
+          </a:bodyPr>
+          <a:lstStyle/>
+          <a:p>
+            <a:pPr algn="l">
+              <a:defRPr sz="1600" b="0">
+                <a:solidFill>
+                  <a:srgbClr val="E8E8E8"/>
+                </a:solidFill>
+                <a:latin typeface="Calibri"/>
+              </a:defRPr>
+            </a:pPr>
+            <a:r>
+              <a:t>Conformance to the profile's Essential functions when every applicable SHALL is met —</a:t>
+            </a:r>
+            <a:br/>
+            <a:r>
+              <a:t>not conformance to the entire 748-SHALL PHR-S FM model.</a:t>
+            </a:r>
+          </a:p>
+        </p:txBody>
+      </p:sp>
+      <p:sp>
+        <p:nvSpPr>
+          <p:cNvPr id="6" name="TextBox 5"/>
+          <p:cNvSpPr txBox="1"/>
+          <p:nvPr/>
+        </p:nvSpPr>
+        <p:spPr>
+          <a:xfrm>
+            <a:off x="6355080" y="1627632"/>
+            <a:ext cx="3108960" cy="320040"/>
+          </a:xfrm>
+          <a:prstGeom prst="rect">
+            <a:avLst/>
+          </a:prstGeom>
+          <a:noFill/>
+        </p:spPr>
+        <p:txBody>
+          <a:bodyPr wrap="square" anchor="t">
+            <a:spAutoFit/>
+          </a:bodyPr>
+          <a:lstStyle/>
+          <a:p>
+            <a:pPr algn="l">
+              <a:defRPr sz="1800" b="1">
+                <a:solidFill>
+                  <a:srgbClr val="2ECC71"/>
+                </a:solidFill>
+                <a:latin typeface="Calibri"/>
+              </a:defRPr>
+            </a:pPr>
+            <a:r>
+              <a:t>Profile focus</a:t>
+            </a:r>
+          </a:p>
+        </p:txBody>
+      </p:sp>
+      <p:sp>
+        <p:nvSpPr>
+          <p:cNvPr id="7" name="TextBox 6"/>
+          <p:cNvSpPr txBox="1"/>
+          <p:nvPr/>
+        </p:nvSpPr>
+        <p:spPr>
+          <a:xfrm>
+            <a:off x="6355080" y="1984248"/>
+            <a:ext cx="5074920" cy="914400"/>
+          </a:xfrm>
+          <a:prstGeom prst="rect">
+            <a:avLst/>
+          </a:prstGeom>
+          <a:noFill/>
+        </p:spPr>
+        <p:txBody>
+          <a:bodyPr wrap="square" anchor="t">
+            <a:spAutoFit/>
+          </a:bodyPr>
+          <a:lstStyle/>
+          <a:p>
+            <a:pPr algn="l">
+              <a:defRPr sz="1600" b="0">
+                <a:solidFill>
+                  <a:srgbClr val="E8E8E8"/>
+                </a:solidFill>
+                <a:latin typeface="Calibri"/>
+              </a:defRPr>
+            </a:pPr>
+            <a:r>
+              <a:t>Account-holder care, consent and messaging, plus the core trust infrastructure:</a:t>
+            </a:r>
+            <a:br/>
+            <a:r>
+              <a:t>authentication, authorization, audit, terminology and FHIR interoperability.</a:t>
+            </a:r>
+          </a:p>
+        </p:txBody>
+      </p:sp>
+      <p:sp>
+        <p:nvSpPr>
+          <p:cNvPr id="8" name="TextBox 7"/>
+          <p:cNvSpPr txBox="1"/>
+          <p:nvPr/>
+        </p:nvSpPr>
+        <p:spPr>
+          <a:xfrm>
+            <a:off x="731520" y="3182112"/>
+            <a:ext cx="3246120" cy="384048"/>
+          </a:xfrm>
+          <a:prstGeom prst="rect">
+            <a:avLst/>
+          </a:prstGeom>
+          <a:noFill/>
+        </p:spPr>
+        <p:txBody>
+          <a:bodyPr wrap="square" anchor="t">
+            <a:spAutoFit/>
+          </a:bodyPr>
+          <a:lstStyle/>
+          <a:p>
+            <a:pPr algn="l">
+              <a:defRPr sz="1600" b="1">
+                <a:solidFill>
+                  <a:srgbClr val="2ECC71"/>
+                </a:solidFill>
+                <a:latin typeface="Calibri"/>
+              </a:defRPr>
+            </a:pPr>
+            <a:r>
+              <a:t>Personal Health</a:t>
+            </a:r>
+          </a:p>
+        </p:txBody>
+      </p:sp>
+      <p:sp>
+        <p:nvSpPr>
+          <p:cNvPr id="9" name="TextBox 8"/>
+          <p:cNvSpPr txBox="1"/>
+          <p:nvPr/>
+        </p:nvSpPr>
+        <p:spPr>
+          <a:xfrm>
+            <a:off x="3886200" y="3182112"/>
+            <a:ext cx="7315200" cy="512064"/>
+          </a:xfrm>
+          <a:prstGeom prst="rect">
+            <a:avLst/>
+          </a:prstGeom>
+          <a:noFill/>
+        </p:spPr>
+        <p:txBody>
+          <a:bodyPr wrap="square" anchor="t">
+            <a:spAutoFit/>
+          </a:bodyPr>
+          <a:lstStyle/>
+          <a:p>
+            <a:pPr algn="l">
+              <a:defRPr sz="1400" b="0">
+                <a:solidFill>
+                  <a:srgbClr val="E8E8E8"/>
+                </a:solidFill>
+                <a:latin typeface="Calibri"/>
+              </a:defRPr>
+            </a:pPr>
+            <a:r>
+              <a:t>Account-holder record, demographics, advance directives, consents, patient data, FHIR export, observations and secure messaging.</a:t>
+            </a:r>
+          </a:p>
+        </p:txBody>
+      </p:sp>
+      <p:sp>
+        <p:nvSpPr>
+          <p:cNvPr id="10" name="TextBox 9"/>
+          <p:cNvSpPr txBox="1"/>
+          <p:nvPr/>
+        </p:nvSpPr>
+        <p:spPr>
+          <a:xfrm>
+            <a:off x="731520" y="3886200"/>
+            <a:ext cx="3246120" cy="384048"/>
+          </a:xfrm>
+          <a:prstGeom prst="rect">
+            <a:avLst/>
+          </a:prstGeom>
+          <a:noFill/>
+        </p:spPr>
+        <p:txBody>
+          <a:bodyPr wrap="square" anchor="t">
+            <a:spAutoFit/>
+          </a:bodyPr>
+          <a:lstStyle/>
+          <a:p>
+            <a:pPr algn="l">
+              <a:defRPr sz="1600" b="1">
+                <a:solidFill>
+                  <a:srgbClr val="2ECC71"/>
+                </a:solidFill>
+                <a:latin typeface="Calibri"/>
+              </a:defRPr>
+            </a:pPr>
+            <a:r>
+              <a:t>Trust Infrastructure</a:t>
+            </a:r>
+          </a:p>
+        </p:txBody>
+      </p:sp>
+      <p:sp>
+        <p:nvSpPr>
+          <p:cNvPr id="11" name="TextBox 10"/>
+          <p:cNvSpPr txBox="1"/>
+          <p:nvPr/>
+        </p:nvSpPr>
+        <p:spPr>
+          <a:xfrm>
+            <a:off x="3886200" y="3886200"/>
+            <a:ext cx="7315200" cy="512064"/>
+          </a:xfrm>
+          <a:prstGeom prst="rect">
+            <a:avLst/>
+          </a:prstGeom>
+          <a:noFill/>
+        </p:spPr>
+        <p:txBody>
+          <a:bodyPr wrap="square" anchor="t">
+            <a:spAutoFit/>
+          </a:bodyPr>
+          <a:lstStyle/>
+          <a:p>
+            <a:pPr algn="l">
+              <a:defRPr sz="1400" b="0">
+                <a:solidFill>
+                  <a:srgbClr val="E8E8E8"/>
+                </a:solidFill>
+                <a:latin typeface="Calibri"/>
+              </a:defRPr>
+            </a:pPr>
+            <a:r>
+              <a:t>Security and access control; FHIR AuditEvent, retention, review and break-glass; OMOP terminology; FHIR R4 integration.</a:t>
+            </a:r>
+          </a:p>
+        </p:txBody>
+      </p:sp>
+      <p:sp>
+        <p:nvSpPr>
+          <p:cNvPr id="12" name="TextBox 11"/>
+          <p:cNvSpPr txBox="1"/>
+          <p:nvPr/>
+        </p:nvSpPr>
+        <p:spPr>
+          <a:xfrm>
+            <a:off x="731520" y="4590288"/>
+            <a:ext cx="3246120" cy="384048"/>
+          </a:xfrm>
+          <a:prstGeom prst="rect">
+            <a:avLst/>
+          </a:prstGeom>
+          <a:noFill/>
+        </p:spPr>
+        <p:txBody>
+          <a:bodyPr wrap="square" anchor="t">
+            <a:spAutoFit/>
+          </a:bodyPr>
+          <a:lstStyle/>
+          <a:p>
+            <a:pPr algn="l">
+              <a:defRPr sz="1600" b="1">
+                <a:solidFill>
+                  <a:srgbClr val="F39C12"/>
+                </a:solidFill>
+                <a:latin typeface="Calibri"/>
+              </a:defRPr>
+            </a:pPr>
+            <a:r>
+              <a:t>Explicit exclusions</a:t>
+            </a:r>
+          </a:p>
+        </p:txBody>
+      </p:sp>
+      <p:sp>
+        <p:nvSpPr>
+          <p:cNvPr id="13" name="TextBox 12"/>
+          <p:cNvSpPr txBox="1"/>
+          <p:nvPr/>
+        </p:nvSpPr>
+        <p:spPr>
+          <a:xfrm>
+            <a:off x="3886200" y="4590288"/>
+            <a:ext cx="7315200" cy="512064"/>
+          </a:xfrm>
+          <a:prstGeom prst="rect">
+            <a:avLst/>
+          </a:prstGeom>
+          <a:noFill/>
+        </p:spPr>
+        <p:txBody>
+          <a:bodyPr wrap="square" anchor="t">
+            <a:spAutoFit/>
+          </a:bodyPr>
+          <a:lstStyle/>
+          <a:p>
+            <a:pPr algn="l">
+              <a:defRPr sz="1400" b="0">
+                <a:solidFill>
+                  <a:srgbClr val="E8E8E8"/>
+                </a:solidFill>
+                <a:latin typeface="Calibri"/>
+              </a:defRPr>
+            </a:pPr>
+            <a:r>
+              <a:t>Record-lifecycle mega-cluster, most provider/financial/research functions, education, decision support, operations and platform services.</a:t>
+            </a:r>
+          </a:p>
+        </p:txBody>
+      </p:sp>
+      <p:sp>
+        <p:nvSpPr>
+          <p:cNvPr id="14" name="TextBox 13"/>
+          <p:cNvSpPr txBox="1"/>
+          <p:nvPr/>
+        </p:nvSpPr>
+        <p:spPr>
+          <a:xfrm>
+            <a:off x="731520" y="5989320"/>
+            <a:ext cx="10698480" cy="274320"/>
+          </a:xfrm>
+          <a:prstGeom prst="rect">
+            <a:avLst/>
+          </a:prstGeom>
+          <a:noFill/>
+        </p:spPr>
+        <p:txBody>
+          <a:bodyPr wrap="square" anchor="t">
+            <a:spAutoFit/>
+          </a:bodyPr>
+          <a:lstStyle/>
+          <a:p>
+            <a:pPr algn="l">
+              <a:defRPr sz="1200" b="0">
+                <a:solidFill>
+                  <a:srgbClr val="BBBBBB"/>
+                </a:solidFill>
+                <a:latin typeface="Calibri"/>
+              </a:defRPr>
+            </a:pPr>
+            <a:r>
+              <a:t>Source of truth: docs/phrs-fm-onco-profile.md  •  Profile v0.4  •  Re-verified 2026-07-27</a:t>
+            </a:r>
+          </a:p>
+        </p:txBody>
+      </p:sp>
+    </p:spTree>
+  </p:cSld>
+  <p:clrMapOvr>
+    <a:masterClrMapping/>
+  </p:clrMapOvr>
+</p:sld>
+</file>
+
+<file path=ppt/slides/slide27.xml><?xml version="1.0" encoding="utf-8"?>
+<p:sld xmlns:a="http://schemas.openxmlformats.org/drawingml/2006/main" xmlns:p="http://schemas.openxmlformats.org/presentationml/2006/main" xmlns:r="http://schemas.openxmlformats.org/officeDocument/2006/relationships">
+  <p:cSld>
+    <p:bg>
+      <p:bgPr>
+        <a:solidFill>
+          <a:srgbClr val="0F172A"/>
+        </a:solidFill>
+        <a:effectLst/>
+      </p:bgPr>
+    </p:bg>
+    <p:spTree>
+      <p:nvGrpSpPr>
+        <p:cNvPr id="1" name=""/>
+        <p:cNvGrpSpPr/>
+        <p:nvPr/>
+      </p:nvGrpSpPr>
+      <p:grpSpPr/>
+      <p:sp>
+        <p:nvSpPr>
+          <p:cNvPr id="2" name="TextBox 1"/>
+          <p:cNvSpPr txBox="1"/>
+          <p:nvPr/>
+        </p:nvSpPr>
+        <p:spPr>
+          <a:xfrm>
+            <a:off x="731520" y="365760"/>
+            <a:ext cx="10698480" cy="502920"/>
+          </a:xfrm>
+          <a:prstGeom prst="rect">
+            <a:avLst/>
+          </a:prstGeom>
+          <a:noFill/>
+        </p:spPr>
+        <p:txBody>
+          <a:bodyPr wrap="square" anchor="t">
+            <a:spAutoFit/>
+          </a:bodyPr>
+          <a:lstStyle/>
+          <a:p>
+            <a:pPr algn="l">
+              <a:defRPr sz="3200" b="1">
+                <a:solidFill>
+                  <a:srgbClr val="0096D6"/>
+                </a:solidFill>
+                <a:latin typeface="Calibri"/>
+              </a:defRPr>
+            </a:pPr>
+            <a:r>
+              <a:t>Profile-Aware Development</a:t>
+            </a:r>
+          </a:p>
+        </p:txBody>
+      </p:sp>
+      <p:sp>
+        <p:nvSpPr>
+          <p:cNvPr id="3" name="TextBox 2"/>
+          <p:cNvSpPr txBox="1"/>
+          <p:nvPr/>
+        </p:nvSpPr>
+        <p:spPr>
+          <a:xfrm>
+            <a:off x="731520" y="1024128"/>
+            <a:ext cx="10607040" cy="365760"/>
+          </a:xfrm>
+          <a:prstGeom prst="rect">
+            <a:avLst/>
+          </a:prstGeom>
+          <a:noFill/>
+        </p:spPr>
+        <p:txBody>
+          <a:bodyPr wrap="square" anchor="t">
+            <a:spAutoFit/>
+          </a:bodyPr>
+          <a:lstStyle/>
+          <a:p>
+            <a:pPr algn="l">
+              <a:defRPr sz="1700" b="0">
+                <a:solidFill>
+                  <a:srgbClr val="E8E8E8"/>
+                </a:solidFill>
+                <a:latin typeface="Calibri"/>
+              </a:defRPr>
+            </a:pPr>
+            <a:r>
+              <a:t>Feature work that touches profile scope must preserve the evidence behind the conformance claim.</a:t>
+            </a:r>
+          </a:p>
+        </p:txBody>
+      </p:sp>
+      <p:sp>
+        <p:nvSpPr>
+          <p:cNvPr id="4" name="TextBox 3"/>
+          <p:cNvSpPr txBox="1"/>
+          <p:nvPr/>
+        </p:nvSpPr>
+        <p:spPr>
+          <a:xfrm>
+            <a:off x="731520" y="1664208"/>
+            <a:ext cx="3246120" cy="384048"/>
+          </a:xfrm>
+          <a:prstGeom prst="rect">
+            <a:avLst/>
+          </a:prstGeom>
+          <a:noFill/>
+        </p:spPr>
+        <p:txBody>
+          <a:bodyPr wrap="square" anchor="t">
+            <a:spAutoFit/>
+          </a:bodyPr>
+          <a:lstStyle/>
+          <a:p>
+            <a:pPr algn="l">
+              <a:defRPr sz="1600" b="1">
+                <a:solidFill>
+                  <a:srgbClr val="2ECC71"/>
+                </a:solidFill>
+                <a:latin typeface="Calibri"/>
+              </a:defRPr>
+            </a:pPr>
+            <a:r>
+              <a:t>Patient control</a:t>
+            </a:r>
+          </a:p>
+        </p:txBody>
+      </p:sp>
+      <p:sp>
+        <p:nvSpPr>
+          <p:cNvPr id="5" name="TextBox 4"/>
+          <p:cNvSpPr txBox="1"/>
+          <p:nvPr/>
+        </p:nvSpPr>
+        <p:spPr>
+          <a:xfrm>
+            <a:off x="3886200" y="1664208"/>
+            <a:ext cx="7315200" cy="512064"/>
+          </a:xfrm>
+          <a:prstGeom prst="rect">
+            <a:avLst/>
+          </a:prstGeom>
+          <a:noFill/>
+        </p:spPr>
+        <p:txBody>
+          <a:bodyPr wrap="square" anchor="t">
+            <a:spAutoFit/>
+          </a:bodyPr>
+          <a:lstStyle/>
+          <a:p>
+            <a:pPr algn="l">
+              <a:defRPr sz="1400" b="0">
+                <a:solidFill>
+                  <a:srgbClr val="E8E8E8"/>
+                </a:solidFill>
+                <a:latin typeface="Calibri"/>
+              </a:defRPr>
+            </a:pPr>
+            <a:r>
+              <a:t>Keep account-holder data, consent, advance-directive and messaging flows self-scoped; protect patient isolation and authorized proxy access.</a:t>
+            </a:r>
+          </a:p>
+        </p:txBody>
+      </p:sp>
+      <p:sp>
+        <p:nvSpPr>
+          <p:cNvPr id="6" name="TextBox 5"/>
+          <p:cNvSpPr txBox="1"/>
+          <p:nvPr/>
+        </p:nvSpPr>
+        <p:spPr>
+          <a:xfrm>
+            <a:off x="731520" y="2432304"/>
+            <a:ext cx="3246120" cy="384048"/>
+          </a:xfrm>
+          <a:prstGeom prst="rect">
+            <a:avLst/>
+          </a:prstGeom>
+          <a:noFill/>
+        </p:spPr>
+        <p:txBody>
+          <a:bodyPr wrap="square" anchor="t">
+            <a:spAutoFit/>
+          </a:bodyPr>
+          <a:lstStyle/>
+          <a:p>
+            <a:pPr algn="l">
+              <a:defRPr sz="1600" b="1">
+                <a:solidFill>
+                  <a:srgbClr val="2ECC71"/>
+                </a:solidFill>
+                <a:latin typeface="Calibri"/>
+              </a:defRPr>
+            </a:pPr>
+            <a:r>
+              <a:t>Audit by design</a:t>
+            </a:r>
+          </a:p>
+        </p:txBody>
+      </p:sp>
+      <p:sp>
+        <p:nvSpPr>
+          <p:cNvPr id="7" name="TextBox 6"/>
+          <p:cNvSpPr txBox="1"/>
+          <p:nvPr/>
+        </p:nvSpPr>
+        <p:spPr>
+          <a:xfrm>
+            <a:off x="3886200" y="2432304"/>
+            <a:ext cx="7315200" cy="512064"/>
+          </a:xfrm>
+          <a:prstGeom prst="rect">
+            <a:avLst/>
+          </a:prstGeom>
+          <a:noFill/>
+        </p:spPr>
+        <p:txBody>
+          <a:bodyPr wrap="square" anchor="t">
+            <a:spAutoFit/>
+          </a:bodyPr>
+          <a:lstStyle/>
+          <a:p>
+            <a:pPr algn="l">
+              <a:defRPr sz="1400" b="0">
+                <a:solidFill>
+                  <a:srgbClr val="E8E8E8"/>
+                </a:solidFill>
+                <a:latin typeface="Calibri"/>
+              </a:defRPr>
+            </a:pPr>
+            <a:r>
+              <a:t>Ensure meaningful API, admin and background activity is auditable. Audit evidence is tamper-evident (HMAC + hash chain), not physical WORM storage.</a:t>
+            </a:r>
+          </a:p>
+        </p:txBody>
+      </p:sp>
+      <p:sp>
+        <p:nvSpPr>
+          <p:cNvPr id="8" name="TextBox 7"/>
+          <p:cNvSpPr txBox="1"/>
+          <p:nvPr/>
+        </p:nvSpPr>
+        <p:spPr>
+          <a:xfrm>
+            <a:off x="731520" y="3200400"/>
+            <a:ext cx="3246120" cy="384048"/>
+          </a:xfrm>
+          <a:prstGeom prst="rect">
+            <a:avLst/>
+          </a:prstGeom>
+          <a:noFill/>
+        </p:spPr>
+        <p:txBody>
+          <a:bodyPr wrap="square" anchor="t">
+            <a:spAutoFit/>
+          </a:bodyPr>
+          <a:lstStyle/>
+          <a:p>
+            <a:pPr algn="l">
+              <a:defRPr sz="1600" b="1">
+                <a:solidFill>
+                  <a:srgbClr val="2ECC71"/>
+                </a:solidFill>
+                <a:latin typeface="Calibri"/>
+              </a:defRPr>
+            </a:pPr>
+            <a:r>
+              <a:t>FHIR + OMOP integrity</a:t>
+            </a:r>
+          </a:p>
+        </p:txBody>
+      </p:sp>
+      <p:sp>
+        <p:nvSpPr>
+          <p:cNvPr id="9" name="TextBox 8"/>
+          <p:cNvSpPr txBox="1"/>
+          <p:nvPr/>
+        </p:nvSpPr>
+        <p:spPr>
+          <a:xfrm>
+            <a:off x="3886200" y="3200400"/>
+            <a:ext cx="7315200" cy="512064"/>
+          </a:xfrm>
+          <a:prstGeom prst="rect">
+            <a:avLst/>
+          </a:prstGeom>
+          <a:noFill/>
+        </p:spPr>
+        <p:txBody>
+          <a:bodyPr wrap="square" anchor="t">
+            <a:spAutoFit/>
+          </a:bodyPr>
+          <a:lstStyle/>
+          <a:p>
+            <a:pPr algn="l">
+              <a:defRPr sz="1400" b="0">
+                <a:solidFill>
+                  <a:srgbClr val="E8E8E8"/>
+                </a:solidFill>
+                <a:latin typeface="Calibri"/>
+              </a:defRPr>
+            </a:pPr>
+            <a:r>
+              <a:t>Use declared FHIR R4 interfaces and OMOP terminology. Preserve provenance and verify integrity where supported on clinical ingest/export.</a:t>
+            </a:r>
+          </a:p>
+        </p:txBody>
+      </p:sp>
+      <p:sp>
+        <p:nvSpPr>
+          <p:cNvPr id="10" name="TextBox 9"/>
+          <p:cNvSpPr txBox="1"/>
+          <p:nvPr/>
+        </p:nvSpPr>
+        <p:spPr>
+          <a:xfrm>
+            <a:off x="731520" y="3968496"/>
+            <a:ext cx="3246120" cy="384048"/>
+          </a:xfrm>
+          <a:prstGeom prst="rect">
+            <a:avLst/>
+          </a:prstGeom>
+          <a:noFill/>
+        </p:spPr>
+        <p:txBody>
+          <a:bodyPr wrap="square" anchor="t">
+            <a:spAutoFit/>
+          </a:bodyPr>
+          <a:lstStyle/>
+          <a:p>
+            <a:pPr algn="l">
+              <a:defRPr sz="1600" b="1">
+                <a:solidFill>
+                  <a:srgbClr val="2ECC71"/>
+                </a:solidFill>
+                <a:latin typeface="Calibri"/>
+              </a:defRPr>
+            </a:pPr>
+            <a:r>
+              <a:t>Security controls</a:t>
+            </a:r>
+          </a:p>
+        </p:txBody>
+      </p:sp>
+      <p:sp>
+        <p:nvSpPr>
+          <p:cNvPr id="11" name="TextBox 10"/>
+          <p:cNvSpPr txBox="1"/>
+          <p:nvPr/>
+        </p:nvSpPr>
+        <p:spPr>
+          <a:xfrm>
+            <a:off x="3886200" y="3968496"/>
+            <a:ext cx="7315200" cy="512064"/>
+          </a:xfrm>
+          <a:prstGeom prst="rect">
+            <a:avLst/>
+          </a:prstGeom>
+          <a:noFill/>
+        </p:spPr>
+        <p:txBody>
+          <a:bodyPr wrap="square" anchor="t">
+            <a:spAutoFit/>
+          </a:bodyPr>
+          <a:lstStyle/>
+          <a:p>
+            <a:pPr algn="l">
+              <a:defRPr sz="1400" b="0">
+                <a:solidFill>
+                  <a:srgbClr val="E8E8E8"/>
+                </a:solidFill>
+                <a:latin typeface="Calibri"/>
+              </a:defRPr>
+            </a:pPr>
+            <a:r>
+              <a:t>Maintain password/lockout/reset and force-change paths, field-level revision history, OAuth/org-trust scoping and secure routing.</a:t>
+            </a:r>
+          </a:p>
+        </p:txBody>
+      </p:sp>
+      <p:sp>
+        <p:nvSpPr>
+          <p:cNvPr id="12" name="TextBox 11"/>
+          <p:cNvSpPr txBox="1"/>
+          <p:nvPr/>
+        </p:nvSpPr>
+        <p:spPr>
+          <a:xfrm>
+            <a:off x="731520" y="4736592"/>
+            <a:ext cx="3246120" cy="384048"/>
+          </a:xfrm>
+          <a:prstGeom prst="rect">
+            <a:avLst/>
+          </a:prstGeom>
+          <a:noFill/>
+        </p:spPr>
+        <p:txBody>
+          <a:bodyPr wrap="square" anchor="t">
+            <a:spAutoFit/>
+          </a:bodyPr>
+          <a:lstStyle/>
+          <a:p>
+            <a:pPr algn="l">
+              <a:defRPr sz="1600" b="1">
+                <a:solidFill>
+                  <a:srgbClr val="2ECC71"/>
+                </a:solidFill>
+                <a:latin typeface="Calibri"/>
+              </a:defRPr>
+            </a:pPr>
+            <a:r>
+              <a:t>Documentation + tests</a:t>
+            </a:r>
+          </a:p>
+        </p:txBody>
+      </p:sp>
+      <p:sp>
+        <p:nvSpPr>
+          <p:cNvPr id="13" name="TextBox 12"/>
+          <p:cNvSpPr txBox="1"/>
+          <p:nvPr/>
+        </p:nvSpPr>
+        <p:spPr>
+          <a:xfrm>
+            <a:off x="3886200" y="4736592"/>
+            <a:ext cx="7315200" cy="512064"/>
+          </a:xfrm>
+          <a:prstGeom prst="rect">
+            <a:avLst/>
+          </a:prstGeom>
+          <a:noFill/>
+        </p:spPr>
+        <p:txBody>
+          <a:bodyPr wrap="square" anchor="t">
+            <a:spAutoFit/>
+          </a:bodyPr>
+          <a:lstStyle/>
+          <a:p>
+            <a:pPr algn="l">
+              <a:defRPr sz="1400" b="0">
+                <a:solidFill>
+                  <a:srgbClr val="E8E8E8"/>
+                </a:solidFill>
+                <a:latin typeface="Calibri"/>
+              </a:defRPr>
+            </a:pPr>
+            <a:r>
+              <a:t>Map changed behavior to the profile and traceability matrix; add regression tests and update the self-attestation evidence when a criterion changes.</a:t>
+            </a:r>
+          </a:p>
+        </p:txBody>
+      </p:sp>
+      <p:sp>
+        <p:nvSpPr>
+          <p:cNvPr id="14" name="TextBox 13"/>
+          <p:cNvSpPr txBox="1"/>
+          <p:nvPr/>
+        </p:nvSpPr>
+        <p:spPr>
+          <a:xfrm>
+            <a:off x="731520" y="5760720"/>
+            <a:ext cx="10698480" cy="384048"/>
+          </a:xfrm>
+          <a:prstGeom prst="rect">
+            <a:avLst/>
+          </a:prstGeom>
+          <a:noFill/>
+        </p:spPr>
+        <p:txBody>
+          <a:bodyPr wrap="square" anchor="t">
+            <a:spAutoFit/>
+          </a:bodyPr>
+          <a:lstStyle/>
+          <a:p>
+            <a:pPr algn="l">
+              <a:defRPr sz="1400" b="1">
+                <a:solidFill>
+                  <a:srgbClr val="F39C12"/>
+                </a:solidFill>
+                <a:latin typeface="Calibri"/>
+              </a:defRPr>
+            </a:pPr>
+            <a:r>
+              <a:t>Before a formal external self-attestation, re-run criterion-level verification; passing tests alone do not establish the claim.</a:t>
+            </a:r>
+          </a:p>
+        </p:txBody>
+      </p:sp>
+    </p:spTree>
+  </p:cSld>
+  <p:clrMapOvr>
+    <a:masterClrMapping/>
+  </p:clrMapOvr>
+</p:sld>
+</file>
+
+<file path=ppt/slides/slide28.xml><?xml version="1.0" encoding="utf-8"?>
+<p:sld xmlns:a="http://schemas.openxmlformats.org/drawingml/2006/main" xmlns:p="http://schemas.openxmlformats.org/presentationml/2006/main" xmlns:r="http://schemas.openxmlformats.org/officeDocument/2006/relationships">
+  <p:cSld>
+    <p:bg>
+      <p:bgPr>
+        <a:solidFill>
+          <a:srgbClr val="0F172A"/>
+        </a:solidFill>
+        <a:effectLst/>
+      </p:bgPr>
+    </p:bg>
+    <p:spTree>
+      <p:nvGrpSpPr>
+        <p:cNvPr id="1" name=""/>
+        <p:cNvGrpSpPr/>
+        <p:nvPr/>
+      </p:nvGrpSpPr>
+      <p:grpSpPr/>
+      <p:sp>
+        <p:nvSpPr>
+          <p:cNvPr id="2" name="TextBox 1"/>
+          <p:cNvSpPr txBox="1"/>
+          <p:nvPr/>
+        </p:nvSpPr>
+        <p:spPr>
+          <a:xfrm>
+            <a:off x="731520" y="365760"/>
+            <a:ext cx="10698480" cy="502920"/>
+          </a:xfrm>
+          <a:prstGeom prst="rect">
+            <a:avLst/>
+          </a:prstGeom>
+          <a:noFill/>
+        </p:spPr>
+        <p:txBody>
+          <a:bodyPr wrap="square" anchor="t">
+            <a:spAutoFit/>
+          </a:bodyPr>
+          <a:lstStyle/>
+          <a:p>
+            <a:pPr algn="l">
+              <a:defRPr sz="3200" b="1">
+                <a:solidFill>
+                  <a:srgbClr val="0096D6"/>
+                </a:solidFill>
+                <a:latin typeface="Calibri"/>
+              </a:defRPr>
+            </a:pPr>
+            <a:r>
+              <a:t>Self-Attestation Snapshot</a:t>
+            </a:r>
+          </a:p>
+        </p:txBody>
+      </p:sp>
+      <p:sp>
+        <p:nvSpPr>
+          <p:cNvPr id="3" name="TextBox 2"/>
+          <p:cNvSpPr txBox="1"/>
+          <p:nvPr/>
+        </p:nvSpPr>
+        <p:spPr>
+          <a:xfrm>
+            <a:off x="731520" y="1024128"/>
+            <a:ext cx="10607040" cy="365760"/>
+          </a:xfrm>
+          <a:prstGeom prst="rect">
+            <a:avLst/>
+          </a:prstGeom>
+          <a:noFill/>
+        </p:spPr>
+        <p:txBody>
+          <a:bodyPr wrap="square" anchor="t">
+            <a:spAutoFit/>
+          </a:bodyPr>
+          <a:lstStyle/>
+          <a:p>
+            <a:pPr algn="l">
+              <a:defRPr sz="1700" b="0">
+                <a:solidFill>
+                  <a:srgbClr val="E8E8E8"/>
+                </a:solidFill>
+                <a:latin typeface="Calibri"/>
+              </a:defRPr>
+            </a:pPr>
+            <a:r>
+              <a:t>Current documented posture — vendor self-attestation, not HL7 EHR WG validation.</a:t>
+            </a:r>
+          </a:p>
+        </p:txBody>
+      </p:sp>
+      <p:sp>
+        <p:nvSpPr>
+          <p:cNvPr id="4" name="Rounded Rectangle 3"/>
+          <p:cNvSpPr/>
+          <p:nvPr/>
+        </p:nvSpPr>
+        <p:spPr>
+          <a:xfrm>
+            <a:off x="731520" y="1691640"/>
+            <a:ext cx="3383280" cy="1325880"/>
+          </a:xfrm>
+          <a:prstGeom prst="roundRect">
+            <a:avLst/>
+          </a:prstGeom>
+          <a:solidFill>
+            <a:srgbClr val="19263D"/>
+          </a:solidFill>
+          <a:ln>
+            <a:solidFill>
+              <a:srgbClr val="2ECC71"/>
+            </a:solidFill>
+          </a:ln>
+        </p:spPr>
+        <p:style>
+          <a:lnRef idx="1">
+            <a:schemeClr val="accent1"/>
+          </a:lnRef>
+          <a:fillRef idx="3">
+            <a:schemeClr val="accent1"/>
+          </a:fillRef>
+          <a:effectRef idx="2">
+            <a:schemeClr val="accent1"/>
+          </a:effectRef>
+          <a:fontRef idx="minor">
+            <a:schemeClr val="lt1"/>
+          </a:fontRef>
+        </p:style>
+        <p:txBody>
+          <a:bodyPr rtlCol="0" anchor="ctr"/>
+          <a:lstStyle/>
+          <a:p>
+            <a:pPr algn="ctr"/>
+          </a:p>
+        </p:txBody>
+      </p:sp>
+      <p:sp>
+        <p:nvSpPr>
+          <p:cNvPr id="5" name="TextBox 4"/>
+          <p:cNvSpPr txBox="1"/>
+          <p:nvPr/>
+        </p:nvSpPr>
+        <p:spPr>
+          <a:xfrm>
+            <a:off x="731520" y="1847088"/>
+            <a:ext cx="3383280" cy="438912"/>
+          </a:xfrm>
+          <a:prstGeom prst="rect">
+            <a:avLst/>
+          </a:prstGeom>
+          <a:noFill/>
+        </p:spPr>
+        <p:txBody>
+          <a:bodyPr wrap="square" anchor="t">
+            <a:spAutoFit/>
+          </a:bodyPr>
+          <a:lstStyle/>
+          <a:p>
+            <a:pPr algn="ctr">
+              <a:defRPr sz="2600" b="1">
+                <a:solidFill>
+                  <a:srgbClr val="2ECC71"/>
+                </a:solidFill>
+                <a:latin typeface="Calibri"/>
+              </a:defRPr>
+            </a:pPr>
+            <a:r>
+              <a:t>25 / 25</a:t>
+            </a:r>
+          </a:p>
+        </p:txBody>
+      </p:sp>
+      <p:sp>
+        <p:nvSpPr>
+          <p:cNvPr id="6" name="TextBox 5"/>
+          <p:cNvSpPr txBox="1"/>
+          <p:nvPr/>
+        </p:nvSpPr>
+        <p:spPr>
+          <a:xfrm>
+            <a:off x="731520" y="2331720"/>
+            <a:ext cx="3383280" cy="502920"/>
+          </a:xfrm>
+          <a:prstGeom prst="rect">
+            <a:avLst/>
+          </a:prstGeom>
+          <a:noFill/>
+        </p:spPr>
+        <p:txBody>
+          <a:bodyPr wrap="square" anchor="t">
+            <a:spAutoFit/>
+          </a:bodyPr>
+          <a:lstStyle/>
+          <a:p>
+            <a:pPr algn="ctr">
+              <a:defRPr sz="1400" b="0">
+                <a:solidFill>
+                  <a:srgbClr val="E8E8E8"/>
+                </a:solidFill>
+                <a:latin typeface="Calibri"/>
+              </a:defRPr>
+            </a:pPr>
+            <a:r>
+              <a:t>Essential functions</a:t>
+            </a:r>
+            <a:br/>
+            <a:r>
+              <a:t>fully conformant</a:t>
+            </a:r>
+          </a:p>
+        </p:txBody>
+      </p:sp>
+      <p:sp>
+        <p:nvSpPr>
+          <p:cNvPr id="7" name="Rounded Rectangle 6"/>
+          <p:cNvSpPr/>
+          <p:nvPr/>
+        </p:nvSpPr>
+        <p:spPr>
+          <a:xfrm>
+            <a:off x="4389120" y="1691640"/>
+            <a:ext cx="3383280" cy="1325880"/>
+          </a:xfrm>
+          <a:prstGeom prst="roundRect">
+            <a:avLst/>
+          </a:prstGeom>
+          <a:solidFill>
+            <a:srgbClr val="19263D"/>
+          </a:solidFill>
+          <a:ln>
+            <a:solidFill>
+              <a:srgbClr val="2ECC71"/>
+            </a:solidFill>
+          </a:ln>
+        </p:spPr>
+        <p:style>
+          <a:lnRef idx="1">
+            <a:schemeClr val="accent1"/>
+          </a:lnRef>
+          <a:fillRef idx="3">
+            <a:schemeClr val="accent1"/>
+          </a:fillRef>
+          <a:effectRef idx="2">
+            <a:schemeClr val="accent1"/>
+          </a:effectRef>
+          <a:fontRef idx="minor">
+            <a:schemeClr val="lt1"/>
+          </a:fontRef>
+        </p:style>
+        <p:txBody>
+          <a:bodyPr rtlCol="0" anchor="ctr"/>
+          <a:lstStyle/>
+          <a:p>
+            <a:pPr algn="ctr"/>
+          </a:p>
+        </p:txBody>
+      </p:sp>
+      <p:sp>
+        <p:nvSpPr>
+          <p:cNvPr id="8" name="TextBox 7"/>
+          <p:cNvSpPr txBox="1"/>
+          <p:nvPr/>
+        </p:nvSpPr>
+        <p:spPr>
+          <a:xfrm>
+            <a:off x="4389120" y="1847088"/>
+            <a:ext cx="3383280" cy="438912"/>
+          </a:xfrm>
+          <a:prstGeom prst="rect">
+            <a:avLst/>
+          </a:prstGeom>
+          <a:noFill/>
+        </p:spPr>
+        <p:txBody>
+          <a:bodyPr wrap="square" anchor="t">
+            <a:spAutoFit/>
+          </a:bodyPr>
+          <a:lstStyle/>
+          <a:p>
+            <a:pPr algn="ctr">
+              <a:defRPr sz="2600" b="1">
+                <a:solidFill>
+                  <a:srgbClr val="2ECC71"/>
+                </a:solidFill>
+                <a:latin typeface="Calibri"/>
+              </a:defRPr>
+            </a:pPr>
+            <a:r>
+              <a:t>75 / 78</a:t>
+            </a:r>
+          </a:p>
+        </p:txBody>
+      </p:sp>
+      <p:sp>
+        <p:nvSpPr>
+          <p:cNvPr id="9" name="TextBox 8"/>
+          <p:cNvSpPr txBox="1"/>
+          <p:nvPr/>
+        </p:nvSpPr>
+        <p:spPr>
+          <a:xfrm>
+            <a:off x="4389120" y="2331720"/>
+            <a:ext cx="3383280" cy="502920"/>
+          </a:xfrm>
+          <a:prstGeom prst="rect">
+            <a:avLst/>
+          </a:prstGeom>
+          <a:noFill/>
+        </p:spPr>
+        <p:txBody>
+          <a:bodyPr wrap="square" anchor="t">
+            <a:spAutoFit/>
+          </a:bodyPr>
+          <a:lstStyle/>
+          <a:p>
+            <a:pPr algn="ctr">
+              <a:defRPr sz="1400" b="0">
+                <a:solidFill>
+                  <a:srgbClr val="E8E8E8"/>
+                </a:solidFill>
+                <a:latin typeface="Calibri"/>
+              </a:defRPr>
+            </a:pPr>
+            <a:r>
+              <a:t>SHALL criteria MET</a:t>
+            </a:r>
+            <a:br/>
+            <a:r>
+              <a:t>in the evaluated set</a:t>
+            </a:r>
+          </a:p>
+        </p:txBody>
+      </p:sp>
+      <p:sp>
+        <p:nvSpPr>
+          <p:cNvPr id="10" name="Rounded Rectangle 9"/>
+          <p:cNvSpPr/>
+          <p:nvPr/>
+        </p:nvSpPr>
+        <p:spPr>
+          <a:xfrm>
+            <a:off x="8046720" y="1691640"/>
+            <a:ext cx="3383280" cy="1325880"/>
+          </a:xfrm>
+          <a:prstGeom prst="roundRect">
+            <a:avLst/>
+          </a:prstGeom>
+          <a:solidFill>
+            <a:srgbClr val="19263D"/>
+          </a:solidFill>
+          <a:ln>
+            <a:solidFill>
+              <a:srgbClr val="F39C12"/>
+            </a:solidFill>
+          </a:ln>
+        </p:spPr>
+        <p:style>
+          <a:lnRef idx="1">
+            <a:schemeClr val="accent1"/>
+          </a:lnRef>
+          <a:fillRef idx="3">
+            <a:schemeClr val="accent1"/>
+          </a:fillRef>
+          <a:effectRef idx="2">
+            <a:schemeClr val="accent1"/>
+          </a:effectRef>
+          <a:fontRef idx="minor">
+            <a:schemeClr val="lt1"/>
+          </a:fontRef>
+        </p:style>
+        <p:txBody>
+          <a:bodyPr rtlCol="0" anchor="ctr"/>
+          <a:lstStyle/>
+          <a:p>
+            <a:pPr algn="ctr"/>
+          </a:p>
+        </p:txBody>
+      </p:sp>
+      <p:sp>
+        <p:nvSpPr>
+          <p:cNvPr id="11" name="TextBox 10"/>
+          <p:cNvSpPr txBox="1"/>
+          <p:nvPr/>
+        </p:nvSpPr>
+        <p:spPr>
+          <a:xfrm>
+            <a:off x="8046720" y="1847088"/>
+            <a:ext cx="3383280" cy="438912"/>
+          </a:xfrm>
+          <a:prstGeom prst="rect">
+            <a:avLst/>
+          </a:prstGeom>
+          <a:noFill/>
+        </p:spPr>
+        <p:txBody>
+          <a:bodyPr wrap="square" anchor="t">
+            <a:spAutoFit/>
+          </a:bodyPr>
+          <a:lstStyle/>
+          <a:p>
+            <a:pPr algn="ctr">
+              <a:defRPr sz="2600" b="1">
+                <a:solidFill>
+                  <a:srgbClr val="F39C12"/>
+                </a:solidFill>
+                <a:latin typeface="Calibri"/>
+              </a:defRPr>
+            </a:pPr>
+            <a:r>
+              <a:t>3</a:t>
+            </a:r>
+          </a:p>
+        </p:txBody>
+      </p:sp>
+      <p:sp>
+        <p:nvSpPr>
+          <p:cNvPr id="12" name="TextBox 11"/>
+          <p:cNvSpPr txBox="1"/>
+          <p:nvPr/>
+        </p:nvSpPr>
+        <p:spPr>
+          <a:xfrm>
+            <a:off x="8046720" y="2331720"/>
+            <a:ext cx="3383280" cy="502920"/>
+          </a:xfrm>
+          <a:prstGeom prst="rect">
+            <a:avLst/>
+          </a:prstGeom>
+          <a:noFill/>
+        </p:spPr>
+        <p:txBody>
+          <a:bodyPr wrap="square" anchor="t">
+            <a:spAutoFit/>
+          </a:bodyPr>
+          <a:lstStyle/>
+          <a:p>
+            <a:pPr algn="ctr">
+              <a:defRPr sz="1400" b="0">
+                <a:solidFill>
+                  <a:srgbClr val="E8E8E8"/>
+                </a:solidFill>
+                <a:latin typeface="Calibri"/>
+              </a:defRPr>
+            </a:pPr>
+            <a:r>
+              <a:t>PARTIAL criteria —</a:t>
+            </a:r>
+            <a:br/>
+            <a:r>
+              <a:t>Optional only</a:t>
+            </a:r>
+          </a:p>
+        </p:txBody>
+      </p:sp>
+      <p:sp>
+        <p:nvSpPr>
+          <p:cNvPr id="13" name="TextBox 12"/>
+          <p:cNvSpPr txBox="1"/>
+          <p:nvPr/>
+        </p:nvSpPr>
+        <p:spPr>
+          <a:xfrm>
+            <a:off x="731520" y="3456432"/>
+            <a:ext cx="3200400" cy="320040"/>
+          </a:xfrm>
+          <a:prstGeom prst="rect">
+            <a:avLst/>
+          </a:prstGeom>
+          <a:noFill/>
+        </p:spPr>
+        <p:txBody>
+          <a:bodyPr wrap="square" anchor="t">
+            <a:spAutoFit/>
+          </a:bodyPr>
+          <a:lstStyle/>
+          <a:p>
+            <a:pPr algn="l">
+              <a:defRPr sz="1800" b="1">
+                <a:solidFill>
+                  <a:srgbClr val="2ECC71"/>
+                </a:solidFill>
+                <a:latin typeface="Calibri"/>
+              </a:defRPr>
+            </a:pPr>
+            <a:r>
+              <a:t>Remaining Optional scope</a:t>
+            </a:r>
+          </a:p>
+        </p:txBody>
+      </p:sp>
+      <p:sp>
+        <p:nvSpPr>
+          <p:cNvPr id="14" name="TextBox 13"/>
+          <p:cNvSpPr txBox="1"/>
+          <p:nvPr/>
+        </p:nvSpPr>
+        <p:spPr>
+          <a:xfrm>
+            <a:off x="731520" y="3822191"/>
+            <a:ext cx="5303520" cy="749808"/>
+          </a:xfrm>
+          <a:prstGeom prst="rect">
+            <a:avLst/>
+          </a:prstGeom>
+          <a:noFill/>
+        </p:spPr>
+        <p:txBody>
+          <a:bodyPr wrap="square" anchor="t">
+            <a:spAutoFit/>
+          </a:bodyPr>
+          <a:lstStyle/>
+          <a:p>
+            <a:pPr algn="l">
+              <a:defRPr sz="1500" b="0">
+                <a:solidFill>
+                  <a:srgbClr val="E8E8E8"/>
+                </a:solidFill>
+                <a:latin typeface="Calibri"/>
+              </a:defRPr>
+            </a:pPr>
+            <a:r>
+              <a:t>TI.5.2 — FHIR R4 is declared/negotiated; no cross-version transform.</a:t>
+            </a:r>
+            <a:br/>
+            <a:r>
+              <a:t>TI.5.4 — interchange agreements are descriptive, not enforcement-bound.</a:t>
+            </a:r>
+          </a:p>
+        </p:txBody>
+      </p:sp>
+      <p:sp>
+        <p:nvSpPr>
+          <p:cNvPr id="15" name="TextBox 14"/>
+          <p:cNvSpPr txBox="1"/>
+          <p:nvPr/>
+        </p:nvSpPr>
+        <p:spPr>
+          <a:xfrm>
+            <a:off x="6355080" y="3456432"/>
+            <a:ext cx="4663440" cy="320040"/>
+          </a:xfrm>
+          <a:prstGeom prst="rect">
+            <a:avLst/>
+          </a:prstGeom>
+          <a:noFill/>
+        </p:spPr>
+        <p:txBody>
+          <a:bodyPr wrap="square" anchor="t">
+            <a:spAutoFit/>
+          </a:bodyPr>
+          <a:lstStyle/>
+          <a:p>
+            <a:pPr algn="l">
+              <a:defRPr sz="1800" b="1">
+                <a:solidFill>
+                  <a:srgbClr val="2ECC71"/>
+                </a:solidFill>
+                <a:latin typeface="Calibri"/>
+              </a:defRPr>
+            </a:pPr>
+            <a:r>
+              <a:t>Disclosed limits developers should not obscure</a:t>
+            </a:r>
+          </a:p>
+        </p:txBody>
+      </p:sp>
+      <p:sp>
+        <p:nvSpPr>
+          <p:cNvPr id="16" name="TextBox 15"/>
+          <p:cNvSpPr txBox="1"/>
+          <p:nvPr/>
+        </p:nvSpPr>
+        <p:spPr>
+          <a:xfrm>
+            <a:off x="6355080" y="3822191"/>
+            <a:ext cx="4983480" cy="841248"/>
+          </a:xfrm>
+          <a:prstGeom prst="rect">
+            <a:avLst/>
+          </a:prstGeom>
+          <a:noFill/>
+        </p:spPr>
+        <p:txBody>
+          <a:bodyPr wrap="square" anchor="t">
+            <a:spAutoFit/>
+          </a:bodyPr>
+          <a:lstStyle/>
+          <a:p>
+            <a:pPr algn="l">
+              <a:defRPr sz="1500" b="0">
+                <a:solidFill>
+                  <a:srgbClr val="E8E8E8"/>
+                </a:solidFill>
+                <a:latin typeface="Calibri"/>
+              </a:defRPr>
+            </a:pPr>
+            <a:r>
+              <a:t>Audit tail truncation needs an external chain-hash anchor. Export HMAC is symmetric, not third-party non-repudiation. Ingest digest verification is opt-in.</a:t>
+            </a:r>
+          </a:p>
+        </p:txBody>
+      </p:sp>
+      <p:sp>
+        <p:nvSpPr>
+          <p:cNvPr id="17" name="TextBox 16"/>
+          <p:cNvSpPr txBox="1"/>
+          <p:nvPr/>
+        </p:nvSpPr>
+        <p:spPr>
+          <a:xfrm>
+            <a:off x="731520" y="5806440"/>
+            <a:ext cx="10698480" cy="347472"/>
+          </a:xfrm>
+          <a:prstGeom prst="rect">
+            <a:avLst/>
+          </a:prstGeom>
+          <a:noFill/>
+        </p:spPr>
+        <p:txBody>
+          <a:bodyPr wrap="square" anchor="t">
+            <a:spAutoFit/>
+          </a:bodyPr>
+          <a:lstStyle/>
+          <a:p>
+            <a:pPr algn="l">
+              <a:defRPr sz="1300" b="0">
+                <a:solidFill>
+                  <a:srgbClr val="BBBBBB"/>
+                </a:solidFill>
+                <a:latin typeface="Calibri"/>
+              </a:defRPr>
+            </a:pPr>
+            <a:r>
+              <a:t>Evidence: docs/phrs-fm-conformance-claim.md  •  docs/phrs-fm-traceability.md  •  Update these artifacts with any profile-relevant change.</a:t>
             </a:r>
           </a:p>
         </p:txBody>

</xml_diff>